<commit_message>
Deck: credit Claude Code in the footer, point to the full report, cite the report's provenance statement
Numbers recomputed against the corrected data; none changed.

Co-Authored-By: Claude Opus 5.5 <noreply@anthropic.com>
</commit_message>
<xml_diff>
--- a/presentations/lef_forum_2026/Leverett school spending in context - LEF forum 2026-11.pptx
+++ b/presentations/lef_forum_2026/Leverett school spending in context - LEF forum 2026-11.pptx
@@ -111,27 +111,27 @@
   <p:extLst>
     <p:ext uri="{521415D9-36F7-43E2-AB2F-B90AF26B5E84}">
       <p14:sectionLst xmlns:p14="http://schemas.microsoft.com/office/powerpoint/2010/main">
-        <p14:section name="Opening" id="{5f109bf6-85b5-6a2f-8fba-e2ad3e326250}">
+        <p14:section name="Opening" id="{0db079a8-51ab-5665-d282-c8a7ee28031f}">
           <p14:sldIdLst>
             <p14:sldId id="256"/>
           </p14:sldIdLst>
         </p14:section>
-        <p14:section name="Western MA" id="{823ff93d-2612-c055-390f-da662f850b00}">
+        <p14:section name="Western MA" id="{11de07e9-bfd1-6189-1686-36ee0065ee6b}">
           <p14:sldIdLst>
             <p14:sldId id="257"/>
           </p14:sldIdLst>
         </p14:section>
-        <p14:section name="ARPS" id="{b86d34d5-be51-8ef4-ca33-2a3f2a8e35cb}">
+        <p14:section name="ARPS" id="{0cf03c43-6180-1e11-adc5-35c07c5d481e}">
           <p14:sldIdLst>
             <p14:sldId id="258"/>
           </p14:sldIdLst>
         </p14:section>
-        <p14:section name="Leverett" id="{516db02f-33af-1b30-c2f3-ea737f419587}">
+        <p14:section name="Leverett" id="{fcfe0d48-995a-81e4-6208-5148f5f1db08}">
           <p14:sldIdLst>
             <p14:sldId id="259"/>
           </p14:sldIdLst>
         </p14:section>
-        <p14:section name="Pay and funding" id="{72304ef0-1742-cf5a-d484-ee763936472d}">
+        <p14:section name="Pay and funding" id="{0a4dc027-d3af-27c1-6f14-02fae30f9515}">
           <p14:sldIdLst>
             <p14:sldId id="260"/>
           </p14:sldIdLst>
@@ -2686,7 +2686,8 @@
               <a:rPr lang="en-US" dirty="0"/>
               <a:t>Per-pupil expenditure (PPE) is a flawed lens on school budgets: one number hides student needs, buildings, governance and history. It is also the standard the state reports and the public uses, so it is worth understanding in full.
 The comparison group is the 21 Western MA traditional districts with 200 or fewer in-district students in FY2025, the report's "Tiny" cohort definition. Leverett ranks 19 of 21 on FY2025 PPE.
-Inflation uses the CPI-U for the Northeast, averaged over each July–June fiscal year.</a:t>
+Inflation uses the CPI-U for the Northeast, averaged over each July–June fiscal year.
+Source: Western MA Per Pupil Expenditure Report, FY2009–FY2025 edition. As its "How this report was made" statement says, Tim designed the analysis and is responsible for it; Claude Code helped write the code and draft the text. This deck was built the same way.</a:t>
             </a:r>
             <a:endParaRPr lang="en-US" dirty="0"/>
           </a:p>
@@ -3342,7 +3343,7 @@
         <p:spPr>
           <a:xfrm>
             <a:off x="548640" y="6355080"/>
-            <a:ext cx="8229600" cy="274320"/>
+            <a:ext cx="10241280" cy="274320"/>
           </a:xfrm>
           <a:prstGeom prst="rect">
             <a:avLst/>
@@ -3363,7 +3364,7 @@
                   <a:schemeClr val="accent6"/>
                 </a:solidFill>
               </a:rPr>
-              <a:t>Data: Massachusetts DESE, FY2009–FY2025. Analysis: Tim Shores.</a:t>
+              <a:t>Data: Massachusetts DESE, FY2009–FY2025. Analysis: Tim Shores, with Claude Code. Full report: timshores.com/portfolio</a:t>
             </a:r>
             <a:endParaRPr lang="en-US" sz="1000" dirty="0"/>
           </a:p>

</xml_diff>

<commit_message>
LEF deck: inflation demo for Leverett and Amherst-Pelham, town budget slide
Two new slides: per-pupil spending as spent, restated in FY2025 dollars, and
FY2025, for Leverett and Amherst-Pelham; and education's share of Leverett's
general fund against towns its size. Town figures come from the explorer's
export so the deck and the explorer agree. Explorer menus list Gateway Cities.

Co-Authored-By: Claude Opus 5.5 <noreply@anthropic.com>
</commit_message>
<xml_diff>
--- a/presentations/lef_forum_2026/Leverett school spending in context - LEF forum 2026-11.pptx
+++ b/presentations/lef_forum_2026/Leverett school spending in context - LEF forum 2026-11.pptx
@@ -10,9 +10,11 @@
     <p:sldId id="258" r:id="rId4"/>
     <p:sldId id="259" r:id="rId5"/>
     <p:sldId id="260" r:id="rId6"/>
+    <p:sldId id="261" r:id="rId7"/>
+    <p:sldId id="262" r:id="rId8"/>
   </p:sldIdLst>
   <p:notesMasterIdLst>
-    <p:notesMasterId r:id="rId7"/>
+    <p:notesMasterId r:id="rId9"/>
   </p:notesMasterIdLst>
   <p:sldSz cx="12192000" cy="6858000"/>
   <p:notesSz cx="6858000" cy="12192000"/>
@@ -111,29 +113,39 @@
   <p:extLst>
     <p:ext uri="{521415D9-36F7-43E2-AB2F-B90AF26B5E84}">
       <p14:sectionLst xmlns:p14="http://schemas.microsoft.com/office/powerpoint/2010/main">
-        <p14:section name="Opening" id="{7f0ea6ed-68ca-8b8f-7ede-50d36652d0d8}">
+        <p14:section name="Opening" id="{e30535d5-fa7e-7562-683f-7d6400440266}">
           <p14:sldIdLst>
             <p14:sldId id="256"/>
           </p14:sldIdLst>
         </p14:section>
-        <p14:section name="Western MA" id="{dd13479a-128e-2ddb-07c6-8711d3137886}">
+        <p14:section name="Western MA" id="{41960ecd-6e5f-5e75-6f28-32625c2df08a}">
           <p14:sldIdLst>
             <p14:sldId id="257"/>
           </p14:sldIdLst>
         </p14:section>
-        <p14:section name="ARPS" id="{60ccc496-4c74-e084-49c7-e8145b9b3ded}">
+        <p14:section name="ARPS" id="{5894aa99-1f8c-facd-3965-7fac98fd0cf3}">
           <p14:sldIdLst>
             <p14:sldId id="258"/>
           </p14:sldIdLst>
         </p14:section>
-        <p14:section name="Leverett" id="{5b8f7403-c8ac-c59c-8d23-3f107094e78f}">
+        <p14:section name="Inflation" id="{02d08199-f3fc-612d-6b41-684629d9c2fd}">
           <p14:sldIdLst>
             <p14:sldId id="259"/>
           </p14:sldIdLst>
         </p14:section>
-        <p14:section name="Pay and funding" id="{238bb433-84f7-deef-c573-c7e57e0b2e32}">
+        <p14:section name="Leverett" id="{deea18c2-4869-e53b-c9ff-b758b3cacf07}">
           <p14:sldIdLst>
             <p14:sldId id="260"/>
+          </p14:sldIdLst>
+        </p14:section>
+        <p14:section name="Pay and funding" id="{768b1f3c-e02b-44ad-4f76-9941207d5072}">
+          <p14:sldIdLst>
+            <p14:sldId id="261"/>
+          </p14:sldIdLst>
+        </p14:section>
+        <p14:section name="Town budget" id="{bc3c45d4-d210-30e8-2f11-52a574aa76ab}">
+          <p14:sldIdLst>
+            <p14:sldId id="262"/>
           </p14:sldIdLst>
         </p14:section>
       </p14:sectionLst>
@@ -1177,6 +1189,442 @@
                 </a:solidFill>
                 <a:latin typeface="+mn-lt"/>
               </a:rPr>
+              <a:t>Spending per pupil: as spent, and restated in today's dollars</a:t>
+            </a:r>
+          </a:p>
+        </c:rich>
+      </c:tx>
+      <c:layout/>
+      <c:overlay val="0"/>
+    </c:title>
+    <c:autoTitleDeleted val="0"/>
+    <c:plotArea>
+      <c:layout/>
+      <c:barChart>
+        <c:barDir val="col"/>
+        <c:grouping val="clustered"/>
+        <c:varyColors val="0"/>
+        <c:ser>
+          <c:idx val="0"/>
+          <c:order val="0"/>
+          <c:tx>
+            <c:strRef>
+              <c:f>Sheet1!$B$1</c:f>
+              <c:strCache>
+                <c:ptCount val="1"/>
+                <c:pt idx="0">
+                  <c:v>FY2009, as spent</c:v>
+                </c:pt>
+              </c:strCache>
+            </c:strRef>
+          </c:tx>
+          <c:spPr>
+            <a:solidFill>
+              <a:srgbClr val="9DB5AC"/>
+            </a:solidFill>
+            <a:effectLst/>
+          </c:spPr>
+          <c:invertIfNegative val="0"/>
+          <c:dLbls>
+            <c:numFmt formatCode="$#,##0" sourceLinked="0"/>
+            <c:txPr>
+              <a:bodyPr/>
+              <a:lstStyle/>
+              <a:p>
+                <a:pPr>
+                  <a:defRPr b="0" i="0" strike="noStrike" sz="1100" u="none">
+                    <a:solidFill>
+                      <a:srgbClr val="1F2A2E"/>
+                    </a:solidFill>
+                    <a:latin typeface="+mn-lt"/>
+                  </a:defRPr>
+                </a:pPr>
+              </a:p>
+            </c:txPr>
+            <c:showLegendKey val="0"/>
+            <c:showVal val="1"/>
+            <c:showCatName val="0"/>
+            <c:showSerName val="0"/>
+            <c:showPercent val="0"/>
+            <c:showBubbleSize val="0"/>
+            <c:showLeaderLines val="0"/>
+          </c:dLbls>
+          <c:cat>
+            <c:multiLvlStrRef>
+              <c:f>Sheet1!$A$2:$A$3</c:f>
+              <c:multiLvlStrCache>
+                <c:ptCount val="2"/>
+                <c:lvl>
+                  <c:pt idx="0">
+                    <c:v>Leverett</c:v>
+                  </c:pt>
+                  <c:pt idx="1">
+                    <c:v>Amherst-Pelham Regional</c:v>
+                  </c:pt>
+                </c:lvl>
+              </c:multiLvlStrCache>
+            </c:multiLvlStrRef>
+          </c:cat>
+          <c:val>
+            <c:numRef>
+              <c:f>Sheet1!$B$2:$B$3</c:f>
+              <c:numCache>
+                <c:formatCode>General</c:formatCode>
+                <c:ptCount val="2"/>
+                <c:pt idx="0">
+                  <c:v>15156</c:v>
+                </c:pt>
+                <c:pt idx="1">
+                  <c:v>16211</c:v>
+                </c:pt>
+              </c:numCache>
+            </c:numRef>
+          </c:val>
+        </c:ser>
+        <c:ser>
+          <c:idx val="1"/>
+          <c:order val="1"/>
+          <c:tx>
+            <c:strRef>
+              <c:f>Sheet1!$C$1</c:f>
+              <c:strCache>
+                <c:ptCount val="1"/>
+                <c:pt idx="0">
+                  <c:v>FY2009 in FY2025 dollars</c:v>
+                </c:pt>
+              </c:strCache>
+            </c:strRef>
+          </c:tx>
+          <c:spPr>
+            <a:solidFill>
+              <a:srgbClr val="E0A458"/>
+            </a:solidFill>
+            <a:effectLst/>
+          </c:spPr>
+          <c:invertIfNegative val="0"/>
+          <c:dLbls>
+            <c:numFmt formatCode="$#,##0" sourceLinked="0"/>
+            <c:txPr>
+              <a:bodyPr/>
+              <a:lstStyle/>
+              <a:p>
+                <a:pPr>
+                  <a:defRPr b="0" i="0" strike="noStrike" sz="1100" u="none">
+                    <a:solidFill>
+                      <a:srgbClr val="1F2A2E"/>
+                    </a:solidFill>
+                    <a:latin typeface="+mn-lt"/>
+                  </a:defRPr>
+                </a:pPr>
+              </a:p>
+            </c:txPr>
+            <c:showLegendKey val="0"/>
+            <c:showVal val="1"/>
+            <c:showCatName val="0"/>
+            <c:showSerName val="0"/>
+            <c:showPercent val="0"/>
+            <c:showBubbleSize val="0"/>
+            <c:showLeaderLines val="0"/>
+          </c:dLbls>
+          <c:cat>
+            <c:multiLvlStrRef>
+              <c:f>Sheet1!$A$2:$A$3</c:f>
+              <c:multiLvlStrCache>
+                <c:ptCount val="2"/>
+                <c:lvl>
+                  <c:pt idx="0">
+                    <c:v>Leverett</c:v>
+                  </c:pt>
+                  <c:pt idx="1">
+                    <c:v>Amherst-Pelham Regional</c:v>
+                  </c:pt>
+                </c:lvl>
+              </c:multiLvlStrCache>
+            </c:multiLvlStrRef>
+          </c:cat>
+          <c:val>
+            <c:numRef>
+              <c:f>Sheet1!$C$2:$C$3</c:f>
+              <c:numCache>
+                <c:formatCode>General</c:formatCode>
+                <c:ptCount val="2"/>
+                <c:pt idx="0">
+                  <c:v>21806.3</c:v>
+                </c:pt>
+                <c:pt idx="1">
+                  <c:v>23324.2</c:v>
+                </c:pt>
+              </c:numCache>
+            </c:numRef>
+          </c:val>
+        </c:ser>
+        <c:ser>
+          <c:idx val="2"/>
+          <c:order val="2"/>
+          <c:tx>
+            <c:strRef>
+              <c:f>Sheet1!$D$1</c:f>
+              <c:strCache>
+                <c:ptCount val="1"/>
+                <c:pt idx="0">
+                  <c:v>FY2025</c:v>
+                </c:pt>
+              </c:strCache>
+            </c:strRef>
+          </c:tx>
+          <c:spPr>
+            <a:solidFill>
+              <a:srgbClr val="23423A"/>
+            </a:solidFill>
+            <a:effectLst/>
+          </c:spPr>
+          <c:invertIfNegative val="0"/>
+          <c:dLbls>
+            <c:numFmt formatCode="$#,##0" sourceLinked="0"/>
+            <c:txPr>
+              <a:bodyPr/>
+              <a:lstStyle/>
+              <a:p>
+                <a:pPr>
+                  <a:defRPr b="0" i="0" strike="noStrike" sz="1100" u="none">
+                    <a:solidFill>
+                      <a:srgbClr val="1F2A2E"/>
+                    </a:solidFill>
+                    <a:latin typeface="+mn-lt"/>
+                  </a:defRPr>
+                </a:pPr>
+              </a:p>
+            </c:txPr>
+            <c:showLegendKey val="0"/>
+            <c:showVal val="1"/>
+            <c:showCatName val="0"/>
+            <c:showSerName val="0"/>
+            <c:showPercent val="0"/>
+            <c:showBubbleSize val="0"/>
+            <c:showLeaderLines val="0"/>
+          </c:dLbls>
+          <c:cat>
+            <c:multiLvlStrRef>
+              <c:f>Sheet1!$A$2:$A$3</c:f>
+              <c:multiLvlStrCache>
+                <c:ptCount val="2"/>
+                <c:lvl>
+                  <c:pt idx="0">
+                    <c:v>Leverett</c:v>
+                  </c:pt>
+                  <c:pt idx="1">
+                    <c:v>Amherst-Pelham Regional</c:v>
+                  </c:pt>
+                </c:lvl>
+              </c:multiLvlStrCache>
+            </c:multiLvlStrRef>
+          </c:cat>
+          <c:val>
+            <c:numRef>
+              <c:f>Sheet1!$D$2:$D$3</c:f>
+              <c:numCache>
+                <c:formatCode>General</c:formatCode>
+                <c:ptCount val="2"/>
+                <c:pt idx="0">
+                  <c:v>23732</c:v>
+                </c:pt>
+                <c:pt idx="1">
+                  <c:v>27899</c:v>
+                </c:pt>
+              </c:numCache>
+            </c:numRef>
+          </c:val>
+        </c:ser>
+        <c:dLbls>
+          <c:numFmt formatCode="$#,##0" sourceLinked="0"/>
+          <c:txPr>
+            <a:bodyPr/>
+            <a:lstStyle/>
+            <a:p>
+              <a:pPr>
+                <a:defRPr b="0" i="0" strike="noStrike" sz="1100" u="none">
+                  <a:solidFill>
+                    <a:srgbClr val="1F2A2E"/>
+                  </a:solidFill>
+                  <a:latin typeface="+mn-lt"/>
+                </a:defRPr>
+              </a:pPr>
+            </a:p>
+          </c:txPr>
+          <c:showLegendKey val="0"/>
+          <c:showVal val="1"/>
+          <c:showCatName val="0"/>
+          <c:showSerName val="0"/>
+          <c:showPercent val="0"/>
+          <c:showBubbleSize val="0"/>
+          <c:showLeaderLines val="0"/>
+        </c:dLbls>
+        <c:gapWidth val="55"/>
+        <c:overlap val="0"/>
+        <c:axId val="2094734554"/>
+        <c:axId val="2094734552"/>
+        <c:axId val="2094734556"/>
+      </c:barChart>
+      <c:catAx>
+        <c:axId val="2094734554"/>
+        <c:scaling>
+          <c:orientation val="minMax"/>
+        </c:scaling>
+        <c:delete val="0"/>
+        <c:axPos val="b"/>
+        <c:numFmt formatCode="General" sourceLinked="1"/>
+        <c:majorTickMark val="out"/>
+        <c:minorTickMark val="none"/>
+        <c:tickLblPos val="low"/>
+        <c:spPr>
+          <a:ln w="12700" cap="flat">
+            <a:solidFill>
+              <a:srgbClr val="D9DFDC"/>
+            </a:solidFill>
+            <a:prstDash val="solid"/>
+            <a:round/>
+          </a:ln>
+        </c:spPr>
+        <c:txPr>
+          <a:bodyPr/>
+          <a:lstStyle/>
+          <a:p>
+            <a:pPr>
+              <a:defRPr sz="1300" b="0" i="0" u="none" strike="noStrike">
+                <a:solidFill>
+                  <a:srgbClr val="5E6B66"/>
+                </a:solidFill>
+                <a:latin typeface="+mn-lt"/>
+              </a:defRPr>
+            </a:pPr>
+            <a:endParaRPr lang="en-US"/>
+          </a:p>
+        </c:txPr>
+        <c:crossAx val="2094734552"/>
+        <c:crosses val="autoZero"/>
+        <c:auto val="1"/>
+        <c:lblAlgn val="ctr"/>
+        <c:noMultiLvlLbl val="1"/>
+      </c:catAx>
+      <c:valAx>
+        <c:axId val="2094734552"/>
+        <c:scaling>
+          <c:orientation val="minMax"/>
+          <c:min val="0"/>
+        </c:scaling>
+        <c:delete val="0"/>
+        <c:axPos val="l"/>
+        <c:majorGridlines>
+          <c:spPr>
+            <a:ln w="9525" cap="flat">
+              <a:solidFill>
+                <a:srgbClr val="D9DFDC"/>
+              </a:solidFill>
+              <a:prstDash val="solid"/>
+              <a:round/>
+            </a:ln>
+          </c:spPr>
+        </c:majorGridlines>
+        <c:numFmt formatCode="$#,##0" sourceLinked="0"/>
+        <c:majorTickMark val="out"/>
+        <c:minorTickMark val="none"/>
+        <c:tickLblPos val="nextTo"/>
+        <c:spPr>
+          <a:ln w="12700" cap="flat">
+            <a:noFill/>
+            <a:prstDash val="solid"/>
+            <a:round/>
+          </a:ln>
+        </c:spPr>
+        <c:txPr>
+          <a:bodyPr/>
+          <a:lstStyle/>
+          <a:p>
+            <a:pPr>
+              <a:defRPr sz="1200" b="0" i="0" u="none" strike="noStrike">
+                <a:solidFill>
+                  <a:srgbClr val="5E6B66"/>
+                </a:solidFill>
+                <a:latin typeface="+mn-lt"/>
+              </a:defRPr>
+            </a:pPr>
+            <a:endParaRPr lang="en-US"/>
+          </a:p>
+        </c:txPr>
+        <c:crossAx val="2094734554"/>
+        <c:crosses val="autoZero"/>
+        <c:crossBetween val="between"/>
+      </c:valAx>
+      <c:spPr>
+        <a:noFill/>
+        <a:ln>
+          <a:noFill/>
+        </a:ln>
+        <a:effectLst/>
+      </c:spPr>
+    </c:plotArea>
+    <c:legend>
+      <c:legendPos val="b"/>
+      <c:overlay val="0"/>
+      <c:txPr>
+        <a:bodyPr/>
+        <a:lstStyle/>
+        <a:p>
+          <a:pPr>
+            <a:defRPr sz="1300">
+              <a:solidFill>
+                <a:srgbClr val="1F2A2E"/>
+              </a:solidFill>
+              <a:latin typeface="+mn-lt"/>
+              <a:cs typeface="+mn-lt"/>
+            </a:defRPr>
+          </a:pPr>
+          <a:endParaRPr lang="en-US"/>
+        </a:p>
+      </c:txPr>
+    </c:legend>
+    <c:plotVisOnly val="1"/>
+    <c:dispBlanksAs val="span"/>
+  </c:chart>
+  <c:spPr>
+    <a:noFill/>
+    <a:ln>
+      <a:noFill/>
+    </a:ln>
+    <a:effectLst/>
+  </c:spPr>
+  <c:externalData r:id="rId1">
+    <c:autoUpdate val="0"/>
+  </c:externalData>
+</c:chartSpace>
+</file>
+
+<file path=ppt/charts/chart4.xml><?xml version="1.0" encoding="utf-8"?>
+<c:chartSpace xmlns:c="http://schemas.openxmlformats.org/drawingml/2006/chart" xmlns:a="http://schemas.openxmlformats.org/drawingml/2006/main" xmlns:r="http://schemas.openxmlformats.org/officeDocument/2006/relationships">
+  <c:date1904 val="0"/>
+  <c:roundedCorners val="1"/>
+  <c:chart>
+    <c:title>
+      <c:tx>
+        <c:rich>
+          <a:bodyPr/>
+          <a:lstStyle/>
+          <a:p>
+            <a:pPr>
+              <a:defRPr sz="1400" b="0" i="0" u="none" strike="noStrike">
+                <a:solidFill>
+                  <a:srgbClr val="1F2A2E"/>
+                </a:solidFill>
+                <a:latin typeface="+mn-lt"/>
+              </a:defRPr>
+            </a:pPr>
+            <a:r>
+              <a:rPr sz="1400" b="0" i="0" u="none" strike="noStrike">
+                <a:solidFill>
+                  <a:srgbClr val="1F2A2E"/>
+                </a:solidFill>
+                <a:latin typeface="+mn-lt"/>
+              </a:rPr>
               <a:t>Spending per pupil in FY2025 dollars (adjusted for inflation)</a:t>
             </a:r>
           </a:p>
@@ -1930,7 +2378,7 @@
 </c:chartSpace>
 </file>
 
-<file path=ppt/charts/chart4.xml><?xml version="1.0" encoding="utf-8"?>
+<file path=ppt/charts/chart5.xml><?xml version="1.0" encoding="utf-8"?>
 <c:chartSpace xmlns:c="http://schemas.openxmlformats.org/drawingml/2006/chart" xmlns:a="http://schemas.openxmlformats.org/drawingml/2006/main" xmlns:r="http://schemas.openxmlformats.org/officeDocument/2006/relationships">
   <c:date1904 val="0"/>
   <c:roundedCorners val="1"/>
@@ -2231,6 +2679,348 @@
         <c:scaling>
           <c:orientation val="minMax"/>
           <c:max val="120000"/>
+          <c:min val="0"/>
+        </c:scaling>
+        <c:delete val="1"/>
+        <c:axPos val="b"/>
+        <c:numFmt formatCode="General" sourceLinked="0"/>
+        <c:majorTickMark val="out"/>
+        <c:minorTickMark val="none"/>
+        <c:tickLblPos val="low"/>
+        <c:spPr>
+          <a:ln w="12700" cap="flat">
+            <a:noFill/>
+            <a:prstDash val="solid"/>
+            <a:round/>
+          </a:ln>
+        </c:spPr>
+        <c:txPr>
+          <a:bodyPr/>
+          <a:lstStyle/>
+          <a:p>
+            <a:pPr>
+              <a:defRPr sz="1200" b="0" i="0" u="none" strike="noStrike">
+                <a:solidFill>
+                  <a:srgbClr val="5E6B66"/>
+                </a:solidFill>
+                <a:latin typeface="+mn-lt"/>
+              </a:defRPr>
+            </a:pPr>
+            <a:endParaRPr lang="en-US"/>
+          </a:p>
+        </c:txPr>
+        <c:crossAx val="2094734554"/>
+        <c:crosses val="autoZero"/>
+        <c:crossBetween val="between"/>
+      </c:valAx>
+      <c:spPr>
+        <a:noFill/>
+        <a:ln>
+          <a:noFill/>
+        </a:ln>
+        <a:effectLst/>
+      </c:spPr>
+    </c:plotArea>
+    <c:plotVisOnly val="1"/>
+    <c:dispBlanksAs val="span"/>
+  </c:chart>
+  <c:spPr>
+    <a:noFill/>
+    <a:ln>
+      <a:noFill/>
+    </a:ln>
+    <a:effectLst/>
+  </c:spPr>
+  <c:externalData r:id="rId1">
+    <c:autoUpdate val="0"/>
+  </c:externalData>
+</c:chartSpace>
+</file>
+
+<file path=ppt/charts/chart6.xml><?xml version="1.0" encoding="utf-8"?>
+<c:chartSpace xmlns:c="http://schemas.openxmlformats.org/drawingml/2006/chart" xmlns:a="http://schemas.openxmlformats.org/drawingml/2006/main" xmlns:r="http://schemas.openxmlformats.org/officeDocument/2006/relationships">
+  <c:date1904 val="0"/>
+  <c:roundedCorners val="1"/>
+  <c:chart>
+    <c:title>
+      <c:tx>
+        <c:rich>
+          <a:bodyPr/>
+          <a:lstStyle/>
+          <a:p>
+            <a:pPr>
+              <a:defRPr sz="1400" b="0" i="0" u="none" strike="noStrike">
+                <a:solidFill>
+                  <a:srgbClr val="1F2A2E"/>
+                </a:solidFill>
+                <a:latin typeface="+mn-lt"/>
+              </a:defRPr>
+            </a:pPr>
+            <a:r>
+              <a:rPr sz="1400" b="0" i="0" u="none" strike="noStrike">
+                <a:solidFill>
+                  <a:srgbClr val="1F2A2E"/>
+                </a:solidFill>
+                <a:latin typeface="+mn-lt"/>
+              </a:rPr>
+              <a:t>Education's share of town general fund spending, FY2025</a:t>
+            </a:r>
+          </a:p>
+        </c:rich>
+      </c:tx>
+      <c:layout/>
+      <c:overlay val="0"/>
+    </c:title>
+    <c:autoTitleDeleted val="0"/>
+    <c:plotArea>
+      <c:layout/>
+      <c:barChart>
+        <c:barDir val="bar"/>
+        <c:grouping val="clustered"/>
+        <c:varyColors val="0"/>
+        <c:ser>
+          <c:idx val="0"/>
+          <c:order val="0"/>
+          <c:tx>
+            <c:strRef>
+              <c:f>Sheet1!$B$1</c:f>
+              <c:strCache>
+                <c:ptCount val="1"/>
+                <c:pt idx="0">
+                  <c:v>Education's share of general fund spending, FY2025</c:v>
+                </c:pt>
+              </c:strCache>
+            </c:strRef>
+          </c:tx>
+          <c:spPr>
+            <a:solidFill>
+              <a:srgbClr val="C8553D"/>
+            </a:solidFill>
+            <a:effectLst/>
+          </c:spPr>
+          <c:invertIfNegative val="0"/>
+          <c:dLbls>
+            <c:numFmt formatCode="0%" sourceLinked="0"/>
+            <c:txPr>
+              <a:bodyPr/>
+              <a:lstStyle/>
+              <a:p>
+                <a:pPr>
+                  <a:defRPr b="0" i="0" strike="noStrike" sz="1200" u="none">
+                    <a:solidFill>
+                      <a:srgbClr val="1F2A2E"/>
+                    </a:solidFill>
+                    <a:latin typeface="+mn-lt"/>
+                  </a:defRPr>
+                </a:pPr>
+              </a:p>
+            </c:txPr>
+            <c:showLegendKey val="0"/>
+            <c:showVal val="1"/>
+            <c:showCatName val="0"/>
+            <c:showSerName val="0"/>
+            <c:showPercent val="0"/>
+            <c:showBubbleSize val="0"/>
+            <c:showLeaderLines val="0"/>
+          </c:dLbls>
+          <c:dPt>
+            <c:idx val="0"/>
+            <c:invertIfNegative val="0"/>
+            <c:bubble3D val="0"/>
+            <c:spPr>
+              <a:solidFill>
+                <a:srgbClr val="C8553D"/>
+              </a:solidFill>
+              <a:effectLst/>
+            </c:spPr>
+          </c:dPt>
+          <c:dPt>
+            <c:idx val="1"/>
+            <c:invertIfNegative val="0"/>
+            <c:bubble3D val="0"/>
+            <c:spPr>
+              <a:solidFill>
+                <a:srgbClr val="2F6F62"/>
+              </a:solidFill>
+              <a:effectLst/>
+            </c:spPr>
+          </c:dPt>
+          <c:dPt>
+            <c:idx val="2"/>
+            <c:invertIfNegative val="0"/>
+            <c:bubble3D val="0"/>
+            <c:spPr>
+              <a:solidFill>
+                <a:srgbClr val="2F6F62"/>
+              </a:solidFill>
+              <a:effectLst/>
+            </c:spPr>
+          </c:dPt>
+          <c:dPt>
+            <c:idx val="3"/>
+            <c:invertIfNegative val="0"/>
+            <c:bubble3D val="0"/>
+            <c:spPr>
+              <a:solidFill>
+                <a:srgbClr val="2F6F62"/>
+              </a:solidFill>
+              <a:effectLst/>
+            </c:spPr>
+          </c:dPt>
+          <c:dPt>
+            <c:idx val="4"/>
+            <c:invertIfNegative val="0"/>
+            <c:bubble3D val="0"/>
+            <c:spPr>
+              <a:solidFill>
+                <a:srgbClr val="9DB5AC"/>
+              </a:solidFill>
+              <a:effectLst/>
+            </c:spPr>
+          </c:dPt>
+          <c:dPt>
+            <c:idx val="5"/>
+            <c:invertIfNegative val="0"/>
+            <c:bubble3D val="0"/>
+            <c:spPr>
+              <a:solidFill>
+                <a:srgbClr val="9DB5AC"/>
+              </a:solidFill>
+              <a:effectLst/>
+            </c:spPr>
+          </c:dPt>
+          <c:cat>
+            <c:multiLvlStrRef>
+              <c:f>Sheet1!$A$2:$A$7</c:f>
+              <c:multiLvlStrCache>
+                <c:ptCount val="6"/>
+                <c:lvl>
+                  <c:pt idx="0">
+                    <c:v>Leverett</c:v>
+                  </c:pt>
+                  <c:pt idx="1">
+                    <c:v>Shutesbury</c:v>
+                  </c:pt>
+                  <c:pt idx="2">
+                    <c:v>Pelham</c:v>
+                  </c:pt>
+                  <c:pt idx="3">
+                    <c:v>Amherst</c:v>
+                  </c:pt>
+                  <c:pt idx="4">
+                    <c:v>Towns of 1,000–2,499</c:v>
+                  </c:pt>
+                  <c:pt idx="5">
+                    <c:v>All Western MA towns</c:v>
+                  </c:pt>
+                </c:lvl>
+              </c:multiLvlStrCache>
+            </c:multiLvlStrRef>
+          </c:cat>
+          <c:val>
+            <c:numRef>
+              <c:f>Sheet1!$B$2:$B$7</c:f>
+              <c:numCache>
+                <c:formatCode>General</c:formatCode>
+                <c:ptCount val="6"/>
+                <c:pt idx="0">
+                  <c:v>0.6148</c:v>
+                </c:pt>
+                <c:pt idx="1">
+                  <c:v>0.5923</c:v>
+                </c:pt>
+                <c:pt idx="2">
+                  <c:v>0.5791</c:v>
+                </c:pt>
+                <c:pt idx="3">
+                  <c:v>0.5346</c:v>
+                </c:pt>
+                <c:pt idx="4">
+                  <c:v>0.4793</c:v>
+                </c:pt>
+                <c:pt idx="5">
+                  <c:v>0.4637</c:v>
+                </c:pt>
+              </c:numCache>
+            </c:numRef>
+          </c:val>
+        </c:ser>
+        <c:dLbls>
+          <c:numFmt formatCode="0%" sourceLinked="0"/>
+          <c:txPr>
+            <a:bodyPr/>
+            <a:lstStyle/>
+            <a:p>
+              <a:pPr>
+                <a:defRPr b="0" i="0" strike="noStrike" sz="1200" u="none">
+                  <a:solidFill>
+                    <a:srgbClr val="1F2A2E"/>
+                  </a:solidFill>
+                  <a:latin typeface="+mn-lt"/>
+                </a:defRPr>
+              </a:pPr>
+            </a:p>
+          </c:txPr>
+          <c:showLegendKey val="0"/>
+          <c:showVal val="1"/>
+          <c:showCatName val="0"/>
+          <c:showSerName val="0"/>
+          <c:showPercent val="0"/>
+          <c:showBubbleSize val="0"/>
+          <c:showLeaderLines val="0"/>
+        </c:dLbls>
+        <c:gapWidth val="45"/>
+        <c:overlap val="0"/>
+        <c:axId val="2094734554"/>
+        <c:axId val="2094734552"/>
+        <c:axId val="2094734556"/>
+      </c:barChart>
+      <c:catAx>
+        <c:axId val="2094734554"/>
+        <c:scaling>
+          <c:orientation val="minMax"/>
+        </c:scaling>
+        <c:delete val="0"/>
+        <c:axPos val="l"/>
+        <c:numFmt formatCode="General" sourceLinked="1"/>
+        <c:majorTickMark val="out"/>
+        <c:minorTickMark val="none"/>
+        <c:tickLblPos val="nextTo"/>
+        <c:spPr>
+          <a:ln w="12700" cap="flat">
+            <a:solidFill>
+              <a:srgbClr val="D9DFDC"/>
+            </a:solidFill>
+            <a:prstDash val="solid"/>
+            <a:round/>
+          </a:ln>
+        </c:spPr>
+        <c:txPr>
+          <a:bodyPr/>
+          <a:lstStyle/>
+          <a:p>
+            <a:pPr>
+              <a:defRPr sz="1200" b="0" i="0" u="none" strike="noStrike">
+                <a:solidFill>
+                  <a:srgbClr val="5E6B66"/>
+                </a:solidFill>
+                <a:latin typeface="+mn-lt"/>
+              </a:defRPr>
+            </a:pPr>
+            <a:endParaRPr lang="en-US"/>
+          </a:p>
+        </c:txPr>
+        <c:crossAx val="2094734552"/>
+        <c:crosses val="autoZero"/>
+        <c:auto val="1"/>
+        <c:lblAlgn val="ctr"/>
+        <c:noMultiLvlLbl val="1"/>
+      </c:catAx>
+      <c:valAx>
+        <c:axId val="2094734552"/>
+        <c:scaling>
+          <c:orientation val="minMax"/>
+          <c:max val="0.8"/>
           <c:min val="0"/>
         </c:scaling>
         <c:delete val="1"/>
@@ -2957,9 +3747,10 @@
           <a:p>
             <a:r>
               <a:rPr lang="en-US" dirty="0"/>
-              <a:t>In 2009 Leverett spent $15,156 per pupil, above the $14,066 average for the districts that are its size today. In FY2025 it spent $23,732, against $28,924.
-When enrollment fell from 162 to 124, fixed costs were spread over fewer students and per-pupil spending jumped. Enrollment recovered, and since 2014 spending per pupil has grown 1.1% a year in nominal dollars, from $20,935 to $23,732: slower than prices, so it fell after inflation.
-Enrollment here is DESE in-district FTE: Leverett residents plus school-choice students. Foundation enrollment, the residents the town pays for, was 105 in FY2025.</a:t>
+              <a:t>How to read it: the first bar is what each district spent per pupil in FY2009. The second is the same spending in FY2025 dollars, what it would take today to buy what that money bought then. The third is what the district spent in FY2025. The gap between the first two bars is inflation; only the gap between the last two is growth.
+Leverett: $15,156 in FY2009 is $21,806 in FY2025 dollars, against $23,732 spent in FY2025. Inflation accounts for 78% of the increase. Amherst-Pelham Regional: $16,211, $23,324, $27,899; inflation is 61% of the increase.
+Prices here are the CPI-U for the Northeast, averaged over each July–June fiscal year. The report's inflation addendum also uses the federal price index for what state and local governments buy, mostly labor; by that measure the real growth is smaller still.
+The FY2025 dollars switch in the online explorer does this for every district and town: timshores.com/mass-school-spending.</a:t>
             </a:r>
             <a:endParaRPr lang="en-US" dirty="0"/>
           </a:p>
@@ -3047,10 +3838,9 @@
           <a:p>
             <a:r>
               <a:rPr lang="en-US" dirty="0"/>
-              <a:t>Average teacher salary is DESE's figure for each district. It reflects experience and credentials as well as pay scales, and with about 16 teachers Leverett's average moves with a few hires or retirements. FY2018 is the first year DESE reports it in this dataset.
-Leverett: $56,975 in FY2018, $63,065 in FY2025. Districts its size: $63,498 to $72,544. Peer and Western MA averages are weighted by teacher FTE.
-Leverett funds $10,788 per pupil above the state's required minimum (net school spending), against $11,843 for districts its size. Chapter 70 aid and net school spending are per foundation pupil, the residents the district pays for.
-Closing point from the report: structural funding challenges will persist until the Commonwealth changes policy that no region, town or district can change alone. See Rural Schools MA and the July 2022 report A Sustainable Future for Rural Schools.</a:t>
+              <a:t>In 2009 Leverett spent $15,156 per pupil, above the $14,066 average for the districts that are its size today. In FY2025 it spent $23,732, against $28,924.
+When enrollment fell from 162 to 124, fixed costs were spread over fewer students and per-pupil spending jumped. Enrollment recovered, and since 2014 spending per pupil has grown 1.1% a year in nominal dollars, from $20,935 to $23,732: slower than prices, so it fell after inflation.
+Enrollment here is DESE in-district FTE: Leverett residents plus school-choice students. Foundation enrollment, the residents the town pays for, was 105 in FY2025.</a:t>
             </a:r>
             <a:endParaRPr lang="en-US" dirty="0"/>
           </a:p>
@@ -3074,6 +3864,188 @@
             <a:fld id="{F7021451-1387-4CA6-816F-3879F97B5CBC}" type="slidenum">
               <a:rPr lang="en-US"/>
               <a:t>5</a:t>
+            </a:fld>
+            <a:endParaRPr lang="en-US"/>
+          </a:p>
+        </p:txBody>
+      </p:sp>
+    </p:spTree>
+    <p:extLst>
+      <p:ext uri="{BB962C8B-B14F-4D97-AF65-F5344CB8AC3E}">
+        <p14:creationId xmlns:p14="http://schemas.microsoft.com/office/powerpoint/2010/main" val="1024086991"/>
+      </p:ext>
+    </p:extLst>
+  </p:cSld>
+  <p:clrMapOvr>
+    <a:masterClrMapping/>
+  </p:clrMapOvr>
+</p:notes>
+</file>
+
+<file path=ppt/notesSlides/notesSlide6.xml><?xml version="1.0" encoding="utf-8"?>
+<p:notes xmlns:a="http://schemas.openxmlformats.org/drawingml/2006/main" xmlns:r="http://schemas.openxmlformats.org/officeDocument/2006/relationships" xmlns:p="http://schemas.openxmlformats.org/presentationml/2006/main">
+  <p:cSld>
+    <p:spTree>
+      <p:nvGrpSpPr>
+        <p:cNvPr id="1" name=""/>
+        <p:cNvGrpSpPr/>
+        <p:nvPr/>
+      </p:nvGrpSpPr>
+      <p:grpSpPr>
+        <a:xfrm>
+          <a:off x="0" y="0"/>
+          <a:ext cx="0" cy="0"/>
+          <a:chOff x="0" y="0"/>
+          <a:chExt cx="0" cy="0"/>
+        </a:xfrm>
+      </p:grpSpPr>
+      <p:sp>
+        <p:nvSpPr>
+          <p:cNvPr id="2" name="Slide Image Placeholder 1"/>
+          <p:cNvSpPr>
+            <a:spLocks noGrp="1" noRot="1" noChangeAspect="1"/>
+          </p:cNvSpPr>
+          <p:nvPr>
+            <p:ph type="sldImg"/>
+          </p:nvPr>
+        </p:nvSpPr>
+        <p:spPr/>
+      </p:sp>
+      <p:sp>
+        <p:nvSpPr>
+          <p:cNvPr id="3" name="Notes Placeholder 2"/>
+          <p:cNvSpPr>
+            <a:spLocks noGrp="1"/>
+          </p:cNvSpPr>
+          <p:nvPr>
+            <p:ph type="body" idx="1"/>
+          </p:nvPr>
+        </p:nvSpPr>
+        <p:spPr/>
+        <p:txBody>
+          <a:bodyPr/>
+          <a:lstStyle/>
+          <a:p>
+            <a:r>
+              <a:rPr lang="en-US" dirty="0"/>
+              <a:t>Average teacher salary is DESE's figure for each district. It reflects experience and credentials as well as pay scales, and with about 16 teachers Leverett's average moves with a few hires or retirements. FY2018 is the first year DESE reports it in this dataset.
+Leverett: $56,975 in FY2018, $63,065 in FY2025. Districts its size: $63,498 to $72,544. Peer and Western MA averages are weighted by teacher FTE.
+Leverett funds $10,788 per pupil above the state's required minimum (net school spending), against $11,843 for districts its size. Chapter 70 aid and net school spending are per foundation pupil, the residents the district pays for.
+Closing point from the report: structural funding challenges will persist until the Commonwealth changes policy that no region, town or district can change alone. See Rural Schools MA and the July 2022 report A Sustainable Future for Rural Schools.</a:t>
+            </a:r>
+            <a:endParaRPr lang="en-US" dirty="0"/>
+          </a:p>
+        </p:txBody>
+      </p:sp>
+      <p:sp>
+        <p:nvSpPr>
+          <p:cNvPr id="4" name="Slide Number Placeholder 3"/>
+          <p:cNvSpPr>
+            <a:spLocks noGrp="1"/>
+          </p:cNvSpPr>
+          <p:nvPr>
+            <p:ph type="sldNum" sz="quarter" idx="10"/>
+          </p:nvPr>
+        </p:nvSpPr>
+        <p:spPr/>
+        <p:txBody>
+          <a:bodyPr/>
+          <a:lstStyle/>
+          <a:p>
+            <a:fld id="{F7021451-1387-4CA6-816F-3879F97B5CBC}" type="slidenum">
+              <a:rPr lang="en-US"/>
+              <a:t>6</a:t>
+            </a:fld>
+            <a:endParaRPr lang="en-US"/>
+          </a:p>
+        </p:txBody>
+      </p:sp>
+    </p:spTree>
+    <p:extLst>
+      <p:ext uri="{BB962C8B-B14F-4D97-AF65-F5344CB8AC3E}">
+        <p14:creationId xmlns:p14="http://schemas.microsoft.com/office/powerpoint/2010/main" val="1024086991"/>
+      </p:ext>
+    </p:extLst>
+  </p:cSld>
+  <p:clrMapOvr>
+    <a:masterClrMapping/>
+  </p:clrMapOvr>
+</p:notes>
+</file>
+
+<file path=ppt/notesSlides/notesSlide7.xml><?xml version="1.0" encoding="utf-8"?>
+<p:notes xmlns:a="http://schemas.openxmlformats.org/drawingml/2006/main" xmlns:r="http://schemas.openxmlformats.org/officeDocument/2006/relationships" xmlns:p="http://schemas.openxmlformats.org/presentationml/2006/main">
+  <p:cSld>
+    <p:spTree>
+      <p:nvGrpSpPr>
+        <p:cNvPr id="1" name=""/>
+        <p:cNvGrpSpPr/>
+        <p:nvPr/>
+      </p:nvGrpSpPr>
+      <p:grpSpPr>
+        <a:xfrm>
+          <a:off x="0" y="0"/>
+          <a:ext cx="0" cy="0"/>
+          <a:chOff x="0" y="0"/>
+          <a:chExt cx="0" cy="0"/>
+        </a:xfrm>
+      </p:grpSpPr>
+      <p:sp>
+        <p:nvSpPr>
+          <p:cNvPr id="2" name="Slide Image Placeholder 1"/>
+          <p:cNvSpPr>
+            <a:spLocks noGrp="1" noRot="1" noChangeAspect="1"/>
+          </p:cNvSpPr>
+          <p:nvPr>
+            <p:ph type="sldImg"/>
+          </p:nvPr>
+        </p:nvSpPr>
+        <p:spPr/>
+      </p:sp>
+      <p:sp>
+        <p:nvSpPr>
+          <p:cNvPr id="3" name="Notes Placeholder 2"/>
+          <p:cNvSpPr>
+            <a:spLocks noGrp="1"/>
+          </p:cNvSpPr>
+          <p:nvPr>
+            <p:ph type="body" idx="1"/>
+          </p:nvPr>
+        </p:nvSpPr>
+        <p:spPr/>
+        <p:txBody>
+          <a:bodyPr/>
+          <a:lstStyle/>
+          <a:p>
+            <a:r>
+              <a:rPr lang="en-US" dirty="0"/>
+              <a:t>Leverett's town budget is about the size of similar towns' per resident ($4,029 against $4,116), and its residents pay about the same in taxes ($3,624 against $3,561). Within that budget, education takes 61%, against 48% for the 35 Western MA towns of 1,000–2,499 residents: $2,477 per resident against $1,973.
+Education in Schedule A is the town's own school department plus its assessments from regional and vocational districts. Health insurance and pensions for a town's school employees usually sit in fixed costs instead, so education's true share is if anything larger.
+What the state formula requires: in FY2025, Chapter 70 set Leverett's required local contribution at $1,083,930 to Leverett Elementary and $1,102,340 to Amherst-Pelham Regional.
+Per-resident figures divide each town's FY2025 dollars by its Census population estimate (Leverett: 1,863). Every town is in the online explorer's Towns tab: timshores.com/mass-school-spending.</a:t>
+            </a:r>
+            <a:endParaRPr lang="en-US" dirty="0"/>
+          </a:p>
+        </p:txBody>
+      </p:sp>
+      <p:sp>
+        <p:nvSpPr>
+          <p:cNvPr id="4" name="Slide Number Placeholder 3"/>
+          <p:cNvSpPr>
+            <a:spLocks noGrp="1"/>
+          </p:cNvSpPr>
+          <p:nvPr>
+            <p:ph type="sldNum" sz="quarter" idx="10"/>
+          </p:nvPr>
+        </p:nvSpPr>
+        <p:spPr/>
+        <p:txBody>
+          <a:bodyPr/>
+          <a:lstStyle/>
+          <a:p>
+            <a:fld id="{F7021451-1387-4CA6-816F-3879F97B5CBC}" type="slidenum">
+              <a:rPr lang="en-US"/>
+              <a:t>7</a:t>
             </a:fld>
             <a:endParaRPr lang="en-US"/>
           </a:p>
@@ -3364,7 +4336,7 @@
                   <a:schemeClr val="accent6"/>
                 </a:solidFill>
               </a:rPr>
-              <a:t>Data: Massachusetts DESE, FY2009–FY2025. Analysis: Tim Shores, with Claude Code. Full report: timshores.com/portfolio</a:t>
+              <a:t>Data: Massachusetts DESE, FY2009–FY2025. Analysis: Tim Shores, with Claude Code. Report: timshores.com/portfolio · Explorer: timshores.com/mass-school-spending</a:t>
             </a:r>
             <a:endParaRPr lang="en-US" sz="1000" dirty="0"/>
           </a:p>
@@ -4736,7 +5708,7 @@
                   <a:schemeClr val="tx2"/>
                 </a:solidFill>
               </a:rPr>
-              <a:t>Leverett went from above its peers to below them</a:t>
+              <a:t>Most of the growth since 2009 is inflation</a:t>
             </a:r>
             <a:endParaRPr lang="en-US" sz="3200" dirty="0"/>
           </a:p>
@@ -4744,13 +5716,13 @@
       </p:sp>
       <p:graphicFrame>
         <p:nvGraphicFramePr>
-          <p:cNvPr id="3" name="Leverett real PPE chart" descr=""/>
+          <p:cNvPr id="3" name="inflation demo chart" descr=""/>
           <p:cNvGraphicFramePr/>
           <p:nvPr/>
         </p:nvGraphicFramePr>
         <p:xfrm>
           <a:off x="548640" y="1417320"/>
-          <a:ext cx="6949440" cy="4754880"/>
+          <a:ext cx="7223760" cy="4754880"/>
         </p:xfrm>
         <a:graphic xmlns:a="http://schemas.openxmlformats.org/drawingml/2006/main">
           <a:graphicData uri="http://schemas.openxmlformats.org/drawingml/2006/chart">
@@ -4760,14 +5732,14 @@
       </p:graphicFrame>
       <p:sp>
         <p:nvSpPr>
-          <p:cNvPr id="4" name="callout rank"/>
+          <p:cNvPr id="4" name="callout dollar"/>
           <p:cNvSpPr txBox="1"/>
           <p:nvPr/>
         </p:nvSpPr>
         <p:spPr>
           <a:xfrm>
-            <a:off x="7955280" y="1554480"/>
-            <a:ext cx="3657600" cy="960120"/>
+            <a:off x="8229600" y="1554480"/>
+            <a:ext cx="3474720" cy="960120"/>
           </a:xfrm>
           <a:prstGeom prst="rect">
             <a:avLst/>
@@ -4785,13 +5757,13 @@
             <a:r>
               <a:rPr lang="en-US" sz="3000" b="1" dirty="0">
                 <a:solidFill>
-                  <a:schemeClr val="accent1"/>
+                  <a:schemeClr val="tx2"/>
                 </a:solidFill>
                 <a:latin typeface="Cambria" pitchFamily="34" charset="0"/>
                 <a:ea typeface="Cambria" pitchFamily="34" charset="-122"/>
                 <a:cs typeface="Cambria" pitchFamily="34" charset="-120"/>
               </a:rPr>
-              <a:t>19 of 21</a:t>
+              <a:t>$1.00 → $1.44</a:t>
             </a:r>
             <a:endParaRPr lang="en-US" sz="3000" dirty="0"/>
           </a:p>
@@ -4805,7 +5777,7 @@
                   <a:schemeClr val="tx1"/>
                 </a:solidFill>
               </a:rPr>
-              <a:t>Leverett's rank on FY2025 spending per pupil among districts with 200 or fewer students</a:t>
+              <a:t>A dollar spent in FY2009 buys what $1.44 buys in FY2025, by Northeast consumer prices</a:t>
             </a:r>
             <a:endParaRPr lang="en-US" sz="3000" dirty="0"/>
           </a:p>
@@ -4813,14 +5785,14 @@
       </p:sp>
       <p:sp>
         <p:nvSpPr>
-          <p:cNvPr id="5" name="callout since 2014"/>
+          <p:cNvPr id="5" name="callout Leverett"/>
           <p:cNvSpPr txBox="1"/>
           <p:nvPr/>
         </p:nvSpPr>
         <p:spPr>
           <a:xfrm>
-            <a:off x="7955280" y="2880360"/>
-            <a:ext cx="3657600" cy="960120"/>
+            <a:off x="8229600" y="2880360"/>
+            <a:ext cx="3474720" cy="960120"/>
           </a:xfrm>
           <a:prstGeom prst="rect">
             <a:avLst/>
@@ -4844,7 +5816,7 @@
                 <a:ea typeface="Cambria" pitchFamily="34" charset="-122"/>
                 <a:cs typeface="Cambria" pitchFamily="34" charset="-120"/>
               </a:rPr>
-              <a:t>−14%</a:t>
+              <a:t>+57% → +9%</a:t>
             </a:r>
             <a:endParaRPr lang="en-US" sz="3000" dirty="0"/>
           </a:p>
@@ -4858,7 +5830,7 @@
                   <a:schemeClr val="tx1"/>
                 </a:solidFill>
               </a:rPr>
-              <a:t>Change in Leverett's spending per pupil since 2014, after inflation</a:t>
+              <a:t>Leverett's growth in spending per pupil since FY2009, as spent, then after inflation</a:t>
             </a:r>
             <a:endParaRPr lang="en-US" sz="3000" dirty="0"/>
           </a:p>
@@ -4866,14 +5838,14 @@
       </p:sp>
       <p:sp>
         <p:nvSpPr>
-          <p:cNvPr id="6" name="callout enrollment"/>
+          <p:cNvPr id="6" name="callout ARPS"/>
           <p:cNvSpPr txBox="1"/>
           <p:nvPr/>
         </p:nvSpPr>
         <p:spPr>
           <a:xfrm>
-            <a:off x="7955280" y="4206240"/>
-            <a:ext cx="3657600" cy="960120"/>
+            <a:off x="8229600" y="4206240"/>
+            <a:ext cx="3474720" cy="960120"/>
           </a:xfrm>
           <a:prstGeom prst="rect">
             <a:avLst/>
@@ -4897,7 +5869,7 @@
                 <a:ea typeface="Cambria" pitchFamily="34" charset="-122"/>
                 <a:cs typeface="Cambria" pitchFamily="34" charset="-120"/>
               </a:rPr>
-              <a:t>162 → 124 → 137</a:t>
+              <a:t>+72% → +20%</a:t>
             </a:r>
             <a:endParaRPr lang="en-US" sz="3000" dirty="0"/>
           </a:p>
@@ -4911,7 +5883,7 @@
                   <a:schemeClr val="tx1"/>
                 </a:solidFill>
               </a:rPr>
-              <a:t>Students at Leverett Elementary, 2009, 2014 and 2025, residents and school-choice students together</a:t>
+              <a:t>The same for Amherst-Pelham Regional</a:t>
             </a:r>
             <a:endParaRPr lang="en-US" sz="3000" dirty="0"/>
           </a:p>
@@ -5019,7 +5991,7 @@
                   <a:schemeClr val="tx2"/>
                 </a:solidFill>
               </a:rPr>
-              <a:t>Lower teacher pay has held Leverett's costs down</a:t>
+              <a:t>Leverett went from above its peers to below them</a:t>
             </a:r>
             <a:endParaRPr lang="en-US" sz="3200" dirty="0"/>
           </a:p>
@@ -5027,7 +5999,7 @@
       </p:sp>
       <p:graphicFrame>
         <p:nvGraphicFramePr>
-          <p:cNvPr id="3" name="teacher salary chart" descr=""/>
+          <p:cNvPr id="3" name="Leverett real PPE chart" descr=""/>
           <p:cNvGraphicFramePr/>
           <p:nvPr/>
         </p:nvGraphicFramePr>
@@ -5043,7 +6015,7 @@
       </p:graphicFrame>
       <p:sp>
         <p:nvSpPr>
-          <p:cNvPr id="4" name="callout pay gap"/>
+          <p:cNvPr id="4" name="callout rank"/>
           <p:cNvSpPr txBox="1"/>
           <p:nvPr/>
         </p:nvSpPr>
@@ -5074,7 +6046,7 @@
                 <a:ea typeface="Cambria" pitchFamily="34" charset="-122"/>
                 <a:cs typeface="Cambria" pitchFamily="34" charset="-120"/>
               </a:rPr>
-              <a:t>$9,479</a:t>
+              <a:t>19 of 21</a:t>
             </a:r>
             <a:endParaRPr lang="en-US" sz="3000" dirty="0"/>
           </a:p>
@@ -5088,7 +6060,7 @@
                   <a:schemeClr val="tx1"/>
                 </a:solidFill>
               </a:rPr>
-              <a:t>Below the average teacher salary in districts with 200 or fewer students, FY2025</a:t>
+              <a:t>Leverett's rank on FY2025 spending per pupil among districts with 200 or fewer students</a:t>
             </a:r>
             <a:endParaRPr lang="en-US" sz="3000" dirty="0"/>
           </a:p>
@@ -5096,7 +6068,7 @@
       </p:sp>
       <p:sp>
         <p:nvSpPr>
-          <p:cNvPr id="5" name="callout aid"/>
+          <p:cNvPr id="5" name="callout since 2014"/>
           <p:cNvSpPr txBox="1"/>
           <p:nvPr/>
         </p:nvSpPr>
@@ -5121,13 +6093,13 @@
             <a:r>
               <a:rPr lang="en-US" sz="3000" b="1" dirty="0">
                 <a:solidFill>
-                  <a:schemeClr val="tx2"/>
+                  <a:schemeClr val="accent1"/>
                 </a:solidFill>
                 <a:latin typeface="Cambria" pitchFamily="34" charset="0"/>
                 <a:ea typeface="Cambria" pitchFamily="34" charset="-122"/>
                 <a:cs typeface="Cambria" pitchFamily="34" charset="-120"/>
               </a:rPr>
-              <a:t>$3,885 vs $5,560</a:t>
+              <a:t>−14%</a:t>
             </a:r>
             <a:endParaRPr lang="en-US" sz="3000" dirty="0"/>
           </a:p>
@@ -5141,7 +6113,7 @@
                   <a:schemeClr val="tx1"/>
                 </a:solidFill>
               </a:rPr>
-              <a:t>State Chapter 70 aid per pupil: Leverett vs districts with 200 or fewer students</a:t>
+              <a:t>Change in Leverett's spending per pupil since 2014, after inflation</a:t>
             </a:r>
             <a:endParaRPr lang="en-US" sz="3000" dirty="0"/>
           </a:p>
@@ -5149,14 +6121,14 @@
       </p:sp>
       <p:sp>
         <p:nvSpPr>
-          <p:cNvPr id="6" name="takeaway"/>
+          <p:cNvPr id="6" name="callout enrollment"/>
           <p:cNvSpPr txBox="1"/>
           <p:nvPr/>
         </p:nvSpPr>
         <p:spPr>
           <a:xfrm>
             <a:off x="7955280" y="4206240"/>
-            <a:ext cx="3657600" cy="1463040"/>
+            <a:ext cx="3657600" cy="960120"/>
           </a:xfrm>
           <a:prstGeom prst="rect">
             <a:avLst/>
@@ -5172,14 +6144,31 @@
               <a:buNone/>
             </a:pPr>
             <a:r>
-              <a:rPr lang="en-US" sz="1600" i="1" dirty="0">
-                <a:solidFill>
-                  <a:schemeClr val="accent2"/>
-                </a:solidFill>
+              <a:rPr lang="en-US" sz="3000" b="1" dirty="0">
+                <a:solidFill>
+                  <a:schemeClr val="tx2"/>
+                </a:solidFill>
+                <a:latin typeface="Cambria" pitchFamily="34" charset="0"/>
+                <a:ea typeface="Cambria" pitchFamily="34" charset="-122"/>
+                <a:cs typeface="Cambria" pitchFamily="34" charset="-120"/>
               </a:rPr>
-              <a:t>The town carries more of the cost, and its educators absorb part of it in pay. The structural fix sits with the state's funding formula.</a:t>
+              <a:t>162 → 124 → 137</a:t>
             </a:r>
-            <a:endParaRPr lang="en-US" sz="1600" dirty="0"/>
+            <a:endParaRPr lang="en-US" sz="3000" dirty="0"/>
+          </a:p>
+          <a:p>
+            <a:pPr indent="0" marL="0">
+              <a:buNone/>
+            </a:pPr>
+            <a:r>
+              <a:rPr lang="en-US" sz="1400" dirty="0">
+                <a:solidFill>
+                  <a:schemeClr val="tx1"/>
+                </a:solidFill>
+              </a:rPr>
+              <a:t>Students at Leverett Elementary, 2009, 2014 and 2025, residents and school-choice students together</a:t>
+            </a:r>
+            <a:endParaRPr lang="en-US" sz="3000" dirty="0"/>
           </a:p>
         </p:txBody>
       </p:sp>
@@ -5223,6 +6212,591 @@
             <a:fld id="{F7021451-1387-4CA6-816F-3879F97B5CBC}" type="slidenum">
               <a:rPr b="0" lang="en-US"/>
               <a:t>5</a:t>
+            </a:fld>
+            <a:endParaRPr lang="en-US"/>
+          </a:p>
+        </p:txBody>
+      </p:sp>
+    </p:spTree>
+  </p:cSld>
+  <p:clrMapOvr>
+    <a:masterClrMapping/>
+  </p:clrMapOvr>
+</p:sld>
+</file>
+
+<file path=ppt/slides/slide6.xml><?xml version="1.0" encoding="utf-8"?>
+<p:sld xmlns:a="http://schemas.openxmlformats.org/drawingml/2006/main" xmlns:r="http://schemas.openxmlformats.org/officeDocument/2006/relationships" xmlns:p="http://schemas.openxmlformats.org/presentationml/2006/main">
+  <p:cSld name="Slide 6">
+    <p:spTree>
+      <p:nvGrpSpPr>
+        <p:cNvPr id="1" name=""/>
+        <p:cNvGrpSpPr/>
+        <p:nvPr/>
+      </p:nvGrpSpPr>
+      <p:grpSpPr>
+        <a:xfrm>
+          <a:off x="0" y="0"/>
+          <a:ext cx="0" cy="0"/>
+          <a:chOff x="0" y="0"/>
+          <a:chExt cx="0" cy="0"/>
+        </a:xfrm>
+      </p:grpSpPr>
+      <p:sp>
+        <p:nvSpPr>
+          <p:cNvPr id="2" name="Text 0"/>
+          <p:cNvSpPr/>
+          <p:nvPr>
+            <p:ph idx="100" type="title" hasCustomPrompt="1"/>
+          </p:nvPr>
+        </p:nvSpPr>
+        <p:spPr>
+          <a:xfrm>
+            <a:off x="548640" y="320040"/>
+            <a:ext cx="11064240" cy="960120"/>
+          </a:xfrm>
+          <a:prstGeom prst="rect">
+            <a:avLst/>
+          </a:prstGeom>
+          <a:noFill/>
+          <a:ln/>
+        </p:spPr>
+        <p:txBody>
+          <a:bodyPr wrap="square" lIns="0" tIns="0" rIns="0" bIns="0" rtlCol="0" anchor="ctr"/>
+          <a:lstStyle/>
+          <a:p>
+            <a:pPr algn="l" indent="0" marL="0">
+              <a:buNone/>
+            </a:pPr>
+            <a:r>
+              <a:rPr lang="en-US" sz="3200" b="1" dirty="0">
+                <a:solidFill>
+                  <a:schemeClr val="tx2"/>
+                </a:solidFill>
+              </a:rPr>
+              <a:t>Lower teacher pay has held Leverett's costs down</a:t>
+            </a:r>
+            <a:endParaRPr lang="en-US" sz="3200" dirty="0"/>
+          </a:p>
+        </p:txBody>
+      </p:sp>
+      <p:graphicFrame>
+        <p:nvGraphicFramePr>
+          <p:cNvPr id="3" name="teacher salary chart" descr=""/>
+          <p:cNvGraphicFramePr/>
+          <p:nvPr/>
+        </p:nvGraphicFramePr>
+        <p:xfrm>
+          <a:off x="548640" y="1417320"/>
+          <a:ext cx="6949440" cy="4754880"/>
+        </p:xfrm>
+        <a:graphic xmlns:a="http://schemas.openxmlformats.org/drawingml/2006/main">
+          <a:graphicData uri="http://schemas.openxmlformats.org/drawingml/2006/chart">
+            <c:chart xmlns:c="http://schemas.openxmlformats.org/drawingml/2006/chart" r:id="rId1"/>
+          </a:graphicData>
+        </a:graphic>
+      </p:graphicFrame>
+      <p:sp>
+        <p:nvSpPr>
+          <p:cNvPr id="4" name="callout pay gap"/>
+          <p:cNvSpPr txBox="1"/>
+          <p:nvPr/>
+        </p:nvSpPr>
+        <p:spPr>
+          <a:xfrm>
+            <a:off x="7955280" y="1554480"/>
+            <a:ext cx="3657600" cy="960120"/>
+          </a:xfrm>
+          <a:prstGeom prst="rect">
+            <a:avLst/>
+          </a:prstGeom>
+          <a:noFill/>
+          <a:ln/>
+        </p:spPr>
+        <p:txBody>
+          <a:bodyPr wrap="square" lIns="0" tIns="0" rIns="0" bIns="0" rtlCol="0" anchor="t"/>
+          <a:lstStyle/>
+          <a:p>
+            <a:pPr indent="0" marL="0">
+              <a:buNone/>
+            </a:pPr>
+            <a:r>
+              <a:rPr lang="en-US" sz="3000" b="1" dirty="0">
+                <a:solidFill>
+                  <a:schemeClr val="accent1"/>
+                </a:solidFill>
+                <a:latin typeface="Cambria" pitchFamily="34" charset="0"/>
+                <a:ea typeface="Cambria" pitchFamily="34" charset="-122"/>
+                <a:cs typeface="Cambria" pitchFamily="34" charset="-120"/>
+              </a:rPr>
+              <a:t>$9,479</a:t>
+            </a:r>
+            <a:endParaRPr lang="en-US" sz="3000" dirty="0"/>
+          </a:p>
+          <a:p>
+            <a:pPr indent="0" marL="0">
+              <a:buNone/>
+            </a:pPr>
+            <a:r>
+              <a:rPr lang="en-US" sz="1400" dirty="0">
+                <a:solidFill>
+                  <a:schemeClr val="tx1"/>
+                </a:solidFill>
+              </a:rPr>
+              <a:t>Below the average teacher salary in districts with 200 or fewer students, FY2025</a:t>
+            </a:r>
+            <a:endParaRPr lang="en-US" sz="3000" dirty="0"/>
+          </a:p>
+        </p:txBody>
+      </p:sp>
+      <p:sp>
+        <p:nvSpPr>
+          <p:cNvPr id="5" name="callout aid"/>
+          <p:cNvSpPr txBox="1"/>
+          <p:nvPr/>
+        </p:nvSpPr>
+        <p:spPr>
+          <a:xfrm>
+            <a:off x="7955280" y="2880360"/>
+            <a:ext cx="3657600" cy="960120"/>
+          </a:xfrm>
+          <a:prstGeom prst="rect">
+            <a:avLst/>
+          </a:prstGeom>
+          <a:noFill/>
+          <a:ln/>
+        </p:spPr>
+        <p:txBody>
+          <a:bodyPr wrap="square" lIns="0" tIns="0" rIns="0" bIns="0" rtlCol="0" anchor="t"/>
+          <a:lstStyle/>
+          <a:p>
+            <a:pPr indent="0" marL="0">
+              <a:buNone/>
+            </a:pPr>
+            <a:r>
+              <a:rPr lang="en-US" sz="3000" b="1" dirty="0">
+                <a:solidFill>
+                  <a:schemeClr val="tx2"/>
+                </a:solidFill>
+                <a:latin typeface="Cambria" pitchFamily="34" charset="0"/>
+                <a:ea typeface="Cambria" pitchFamily="34" charset="-122"/>
+                <a:cs typeface="Cambria" pitchFamily="34" charset="-120"/>
+              </a:rPr>
+              <a:t>$3,885 vs $5,560</a:t>
+            </a:r>
+            <a:endParaRPr lang="en-US" sz="3000" dirty="0"/>
+          </a:p>
+          <a:p>
+            <a:pPr indent="0" marL="0">
+              <a:buNone/>
+            </a:pPr>
+            <a:r>
+              <a:rPr lang="en-US" sz="1400" dirty="0">
+                <a:solidFill>
+                  <a:schemeClr val="tx1"/>
+                </a:solidFill>
+              </a:rPr>
+              <a:t>State Chapter 70 aid per pupil: Leverett vs districts with 200 or fewer students</a:t>
+            </a:r>
+            <a:endParaRPr lang="en-US" sz="3000" dirty="0"/>
+          </a:p>
+        </p:txBody>
+      </p:sp>
+      <p:sp>
+        <p:nvSpPr>
+          <p:cNvPr id="6" name="takeaway"/>
+          <p:cNvSpPr txBox="1"/>
+          <p:nvPr/>
+        </p:nvSpPr>
+        <p:spPr>
+          <a:xfrm>
+            <a:off x="7955280" y="4206240"/>
+            <a:ext cx="3657600" cy="1463040"/>
+          </a:xfrm>
+          <a:prstGeom prst="rect">
+            <a:avLst/>
+          </a:prstGeom>
+          <a:noFill/>
+          <a:ln/>
+        </p:spPr>
+        <p:txBody>
+          <a:bodyPr wrap="square" lIns="0" tIns="0" rIns="0" bIns="0" rtlCol="0" anchor="t"/>
+          <a:lstStyle/>
+          <a:p>
+            <a:pPr indent="0" marL="0">
+              <a:buNone/>
+            </a:pPr>
+            <a:r>
+              <a:rPr lang="en-US" sz="1600" i="1" dirty="0">
+                <a:solidFill>
+                  <a:schemeClr val="accent2"/>
+                </a:solidFill>
+              </a:rPr>
+              <a:t>The town carries more of the cost, and its educators absorb part of it in pay. The structural fix sits with the state's funding formula.</a:t>
+            </a:r>
+            <a:endParaRPr lang="en-US" sz="1600" dirty="0"/>
+          </a:p>
+        </p:txBody>
+      </p:sp>
+      <p:sp>
+        <p:nvSpPr>
+          <p:cNvPr id="25" name="Slide Number Placeholder 0"/>
+          <p:cNvSpPr>
+            <a:spLocks noGrp="1"/>
+          </p:cNvSpPr>
+          <p:nvPr>
+            <p:ph type="sldNum" sz="quarter" idx="4294967295"/>
+          </p:nvPr>
+        </p:nvSpPr>
+        <p:spPr>
+          <a:xfrm>
+            <a:off x="11155680" y="6355080"/>
+            <a:ext cx="457200" cy="274320"/>
+          </a:xfrm>
+          <a:prstGeom prst="rect">
+            <a:avLst/>
+          </a:prstGeom>
+          <a:extLst>
+            <a:ext uri="{C572A759-6A51-4108-AA02-DFA0A04FC94B}">
+              <ma14:wrappingTextBoxFlag xmlns:ma14="http://schemas.microsoft.com/office/mac/drawingml/2011/main" val="0"/>
+            </a:ext>
+          </a:extLst>
+        </p:spPr>
+        <p:txBody>
+          <a:bodyPr/>
+          <a:lstStyle>
+            <a:lvl1pPr>
+              <a:defRPr sz="1000">
+                <a:solidFill>
+                  <a:schemeClr val="accent6"/>
+                </a:solidFill>
+              </a:defRPr>
+            </a:lvl1pPr>
+          </a:lstStyle>
+          <a:p>
+            <a:pPr algn="r"/>
+            <a:fld id="{F7021451-1387-4CA6-816F-3879F97B5CBC}" type="slidenum">
+              <a:rPr b="0" lang="en-US"/>
+              <a:t>6</a:t>
+            </a:fld>
+            <a:endParaRPr lang="en-US"/>
+          </a:p>
+        </p:txBody>
+      </p:sp>
+    </p:spTree>
+  </p:cSld>
+  <p:clrMapOvr>
+    <a:masterClrMapping/>
+  </p:clrMapOvr>
+</p:sld>
+</file>
+
+<file path=ppt/slides/slide7.xml><?xml version="1.0" encoding="utf-8"?>
+<p:sld xmlns:a="http://schemas.openxmlformats.org/drawingml/2006/main" xmlns:r="http://schemas.openxmlformats.org/officeDocument/2006/relationships" xmlns:p="http://schemas.openxmlformats.org/presentationml/2006/main">
+  <p:cSld name="Slide 7">
+    <p:spTree>
+      <p:nvGrpSpPr>
+        <p:cNvPr id="1" name=""/>
+        <p:cNvGrpSpPr/>
+        <p:nvPr/>
+      </p:nvGrpSpPr>
+      <p:grpSpPr>
+        <a:xfrm>
+          <a:off x="0" y="0"/>
+          <a:ext cx="0" cy="0"/>
+          <a:chOff x="0" y="0"/>
+          <a:chExt cx="0" cy="0"/>
+        </a:xfrm>
+      </p:grpSpPr>
+      <p:sp>
+        <p:nvSpPr>
+          <p:cNvPr id="2" name="Text 0"/>
+          <p:cNvSpPr/>
+          <p:nvPr>
+            <p:ph idx="100" type="title" hasCustomPrompt="1"/>
+          </p:nvPr>
+        </p:nvSpPr>
+        <p:spPr>
+          <a:xfrm>
+            <a:off x="548640" y="320040"/>
+            <a:ext cx="11064240" cy="960120"/>
+          </a:xfrm>
+          <a:prstGeom prst="rect">
+            <a:avLst/>
+          </a:prstGeom>
+          <a:noFill/>
+          <a:ln/>
+        </p:spPr>
+        <p:txBody>
+          <a:bodyPr wrap="square" lIns="0" tIns="0" rIns="0" bIns="0" rtlCol="0" anchor="ctr"/>
+          <a:lstStyle/>
+          <a:p>
+            <a:pPr algn="l" indent="0" marL="0">
+              <a:buNone/>
+            </a:pPr>
+            <a:r>
+              <a:rPr lang="en-US" sz="3200" b="1" dirty="0">
+                <a:solidFill>
+                  <a:schemeClr val="tx2"/>
+                </a:solidFill>
+              </a:rPr>
+              <a:t>Leverett puts more of its budget into schools</a:t>
+            </a:r>
+            <a:endParaRPr lang="en-US" sz="3200" dirty="0"/>
+          </a:p>
+        </p:txBody>
+      </p:sp>
+      <p:graphicFrame>
+        <p:nvGraphicFramePr>
+          <p:cNvPr id="3" name="education share chart" descr=""/>
+          <p:cNvGraphicFramePr/>
+          <p:nvPr/>
+        </p:nvGraphicFramePr>
+        <p:xfrm>
+          <a:off x="548640" y="1417320"/>
+          <a:ext cx="6949440" cy="4526280"/>
+        </p:xfrm>
+        <a:graphic xmlns:a="http://schemas.openxmlformats.org/drawingml/2006/main">
+          <a:graphicData uri="http://schemas.openxmlformats.org/drawingml/2006/chart">
+            <c:chart xmlns:c="http://schemas.openxmlformats.org/drawingml/2006/chart" r:id="rId1"/>
+          </a:graphicData>
+        </a:graphic>
+      </p:graphicFrame>
+      <p:sp>
+        <p:nvSpPr>
+          <p:cNvPr id="4" name="town source"/>
+          <p:cNvSpPr txBox="1"/>
+          <p:nvPr/>
+        </p:nvSpPr>
+        <p:spPr>
+          <a:xfrm>
+            <a:off x="548640" y="5989320"/>
+            <a:ext cx="6949440" cy="274320"/>
+          </a:xfrm>
+          <a:prstGeom prst="rect">
+            <a:avLst/>
+          </a:prstGeom>
+          <a:noFill/>
+          <a:ln/>
+        </p:spPr>
+        <p:txBody>
+          <a:bodyPr wrap="square" lIns="0" tIns="0" rIns="0" bIns="0" rtlCol="0" anchor="ctr"/>
+          <a:lstStyle/>
+          <a:p>
+            <a:pPr indent="0" marL="0">
+              <a:buNone/>
+            </a:pPr>
+            <a:r>
+              <a:rPr lang="en-US" sz="1000" dirty="0">
+                <a:solidFill>
+                  <a:schemeClr val="accent6"/>
+                </a:solidFill>
+              </a:rPr>
+              <a:t>Town budgets: state Division of Local Services (Schedule A). Population: Census Bureau.</a:t>
+            </a:r>
+            <a:endParaRPr lang="en-US" sz="1000" dirty="0"/>
+          </a:p>
+        </p:txBody>
+      </p:sp>
+      <p:sp>
+        <p:nvSpPr>
+          <p:cNvPr id="5" name="callout share"/>
+          <p:cNvSpPr txBox="1"/>
+          <p:nvPr/>
+        </p:nvSpPr>
+        <p:spPr>
+          <a:xfrm>
+            <a:off x="7955280" y="1554480"/>
+            <a:ext cx="3657600" cy="960120"/>
+          </a:xfrm>
+          <a:prstGeom prst="rect">
+            <a:avLst/>
+          </a:prstGeom>
+          <a:noFill/>
+          <a:ln/>
+        </p:spPr>
+        <p:txBody>
+          <a:bodyPr wrap="square" lIns="0" tIns="0" rIns="0" bIns="0" rtlCol="0" anchor="t"/>
+          <a:lstStyle/>
+          <a:p>
+            <a:pPr indent="0" marL="0">
+              <a:buNone/>
+            </a:pPr>
+            <a:r>
+              <a:rPr lang="en-US" sz="3000" b="1" dirty="0">
+                <a:solidFill>
+                  <a:schemeClr val="accent1"/>
+                </a:solidFill>
+                <a:latin typeface="Cambria" pitchFamily="34" charset="0"/>
+                <a:ea typeface="Cambria" pitchFamily="34" charset="-122"/>
+                <a:cs typeface="Cambria" pitchFamily="34" charset="-120"/>
+              </a:rPr>
+              <a:t>61% vs 48%</a:t>
+            </a:r>
+            <a:endParaRPr lang="en-US" sz="3000" dirty="0"/>
+          </a:p>
+          <a:p>
+            <a:pPr indent="0" marL="0">
+              <a:buNone/>
+            </a:pPr>
+            <a:r>
+              <a:rPr lang="en-US" sz="1400" dirty="0">
+                <a:solidFill>
+                  <a:schemeClr val="tx1"/>
+                </a:solidFill>
+              </a:rPr>
+              <a:t>Education's share of spending: Leverett vs the 35 Western MA towns of 1,000–2,499 residents</a:t>
+            </a:r>
+            <a:endParaRPr lang="en-US" sz="3000" dirty="0"/>
+          </a:p>
+        </p:txBody>
+      </p:sp>
+      <p:sp>
+        <p:nvSpPr>
+          <p:cNvPr id="6" name="callout spending"/>
+          <p:cNvSpPr txBox="1"/>
+          <p:nvPr/>
+        </p:nvSpPr>
+        <p:spPr>
+          <a:xfrm>
+            <a:off x="7955280" y="2880360"/>
+            <a:ext cx="3657600" cy="960120"/>
+          </a:xfrm>
+          <a:prstGeom prst="rect">
+            <a:avLst/>
+          </a:prstGeom>
+          <a:noFill/>
+          <a:ln/>
+        </p:spPr>
+        <p:txBody>
+          <a:bodyPr wrap="square" lIns="0" tIns="0" rIns="0" bIns="0" rtlCol="0" anchor="t"/>
+          <a:lstStyle/>
+          <a:p>
+            <a:pPr indent="0" marL="0">
+              <a:buNone/>
+            </a:pPr>
+            <a:r>
+              <a:rPr lang="en-US" sz="3000" b="1" dirty="0">
+                <a:solidFill>
+                  <a:schemeClr val="tx2"/>
+                </a:solidFill>
+                <a:latin typeface="Cambria" pitchFamily="34" charset="0"/>
+                <a:ea typeface="Cambria" pitchFamily="34" charset="-122"/>
+                <a:cs typeface="Cambria" pitchFamily="34" charset="-120"/>
+              </a:rPr>
+              <a:t>$4,029 vs $4,116</a:t>
+            </a:r>
+            <a:endParaRPr lang="en-US" sz="3000" dirty="0"/>
+          </a:p>
+          <a:p>
+            <a:pPr indent="0" marL="0">
+              <a:buNone/>
+            </a:pPr>
+            <a:r>
+              <a:rPr lang="en-US" sz="1400" dirty="0">
+                <a:solidFill>
+                  <a:schemeClr val="tx1"/>
+                </a:solidFill>
+              </a:rPr>
+              <a:t>Total general fund spending per resident: about the same as those towns</a:t>
+            </a:r>
+            <a:endParaRPr lang="en-US" sz="3000" dirty="0"/>
+          </a:p>
+        </p:txBody>
+      </p:sp>
+      <p:sp>
+        <p:nvSpPr>
+          <p:cNvPr id="7" name="callout taxes"/>
+          <p:cNvSpPr txBox="1"/>
+          <p:nvPr/>
+        </p:nvSpPr>
+        <p:spPr>
+          <a:xfrm>
+            <a:off x="7955280" y="4206240"/>
+            <a:ext cx="3657600" cy="960120"/>
+          </a:xfrm>
+          <a:prstGeom prst="rect">
+            <a:avLst/>
+          </a:prstGeom>
+          <a:noFill/>
+          <a:ln/>
+        </p:spPr>
+        <p:txBody>
+          <a:bodyPr wrap="square" lIns="0" tIns="0" rIns="0" bIns="0" rtlCol="0" anchor="t"/>
+          <a:lstStyle/>
+          <a:p>
+            <a:pPr indent="0" marL="0">
+              <a:buNone/>
+            </a:pPr>
+            <a:r>
+              <a:rPr lang="en-US" sz="3000" b="1" dirty="0">
+                <a:solidFill>
+                  <a:schemeClr val="tx2"/>
+                </a:solidFill>
+                <a:latin typeface="Cambria" pitchFamily="34" charset="0"/>
+                <a:ea typeface="Cambria" pitchFamily="34" charset="-122"/>
+                <a:cs typeface="Cambria" pitchFamily="34" charset="-120"/>
+              </a:rPr>
+              <a:t>$3,624 vs $3,561</a:t>
+            </a:r>
+            <a:endParaRPr lang="en-US" sz="3000" dirty="0"/>
+          </a:p>
+          <a:p>
+            <a:pPr indent="0" marL="0">
+              <a:buNone/>
+            </a:pPr>
+            <a:r>
+              <a:rPr lang="en-US" sz="1400" dirty="0">
+                <a:solidFill>
+                  <a:schemeClr val="tx1"/>
+                </a:solidFill>
+              </a:rPr>
+              <a:t>Taxes per resident, the same comparison</a:t>
+            </a:r>
+            <a:endParaRPr lang="en-US" sz="3000" dirty="0"/>
+          </a:p>
+        </p:txBody>
+      </p:sp>
+      <p:sp>
+        <p:nvSpPr>
+          <p:cNvPr id="25" name="Slide Number Placeholder 0"/>
+          <p:cNvSpPr>
+            <a:spLocks noGrp="1"/>
+          </p:cNvSpPr>
+          <p:nvPr>
+            <p:ph type="sldNum" sz="quarter" idx="4294967295"/>
+          </p:nvPr>
+        </p:nvSpPr>
+        <p:spPr>
+          <a:xfrm>
+            <a:off x="11155680" y="6355080"/>
+            <a:ext cx="457200" cy="274320"/>
+          </a:xfrm>
+          <a:prstGeom prst="rect">
+            <a:avLst/>
+          </a:prstGeom>
+          <a:extLst>
+            <a:ext uri="{C572A759-6A51-4108-AA02-DFA0A04FC94B}">
+              <ma14:wrappingTextBoxFlag xmlns:ma14="http://schemas.microsoft.com/office/mac/drawingml/2011/main" val="0"/>
+            </a:ext>
+          </a:extLst>
+        </p:spPr>
+        <p:txBody>
+          <a:bodyPr/>
+          <a:lstStyle>
+            <a:lvl1pPr>
+              <a:defRPr sz="1000">
+                <a:solidFill>
+                  <a:schemeClr val="accent6"/>
+                </a:solidFill>
+              </a:defRPr>
+            </a:lvl1pPr>
+          </a:lstStyle>
+          <a:p>
+            <a:pPr algn="r"/>
+            <a:fld id="{F7021451-1387-4CA6-816F-3879F97B5CBC}" type="slidenum">
+              <a:rPr b="0" lang="en-US"/>
+              <a:t>7</a:t>
             </a:fld>
             <a:endParaRPr lang="en-US"/>
           </a:p>

</xml_diff>

<commit_message>
LEF deck: Leverett Elementary's colors
Co-Authored-By: Claude Opus 5.5 <noreply@anthropic.com>
</commit_message>
<xml_diff>
--- a/presentations/lef_forum_2026/Leverett school spending in context - LEF forum 2026-11.pptx
+++ b/presentations/lef_forum_2026/Leverett school spending in context - LEF forum 2026-11.pptx
@@ -113,37 +113,37 @@
   <p:extLst>
     <p:ext uri="{521415D9-36F7-43E2-AB2F-B90AF26B5E84}">
       <p14:sectionLst xmlns:p14="http://schemas.microsoft.com/office/powerpoint/2010/main">
-        <p14:section name="Opening" id="{e30535d5-fa7e-7562-683f-7d6400440266}">
+        <p14:section name="Opening" id="{bb043b2a-aa29-e195-65f8-98c166ddb9e9}">
           <p14:sldIdLst>
             <p14:sldId id="256"/>
           </p14:sldIdLst>
         </p14:section>
-        <p14:section name="Western MA" id="{41960ecd-6e5f-5e75-6f28-32625c2df08a}">
+        <p14:section name="Western MA" id="{5cab317e-08fe-b321-e4f4-d932cf0e9b93}">
           <p14:sldIdLst>
             <p14:sldId id="257"/>
           </p14:sldIdLst>
         </p14:section>
-        <p14:section name="ARPS" id="{5894aa99-1f8c-facd-3965-7fac98fd0cf3}">
+        <p14:section name="ARPS" id="{f29f3e3c-a7f1-c7b7-02a4-3b6e2dbd9515}">
           <p14:sldIdLst>
             <p14:sldId id="258"/>
           </p14:sldIdLst>
         </p14:section>
-        <p14:section name="Inflation" id="{02d08199-f3fc-612d-6b41-684629d9c2fd}">
+        <p14:section name="Inflation" id="{de98756f-1371-757a-d74f-216d19729e50}">
           <p14:sldIdLst>
             <p14:sldId id="259"/>
           </p14:sldIdLst>
         </p14:section>
-        <p14:section name="Leverett" id="{deea18c2-4869-e53b-c9ff-b758b3cacf07}">
+        <p14:section name="Leverett" id="{db64e497-234a-eaea-5f20-b19d90799ade}">
           <p14:sldIdLst>
             <p14:sldId id="260"/>
           </p14:sldIdLst>
         </p14:section>
-        <p14:section name="Pay and funding" id="{768b1f3c-e02b-44ad-4f76-9941207d5072}">
+        <p14:section name="Pay and funding" id="{ab08a64c-7c6d-f42e-8fef-e84c70d3b5c4}">
           <p14:sldIdLst>
             <p14:sldId id="261"/>
           </p14:sldIdLst>
         </p14:section>
-        <p14:section name="Town budget" id="{bc3c45d4-d210-30e8-2f11-52a574aa76ab}">
+        <p14:section name="Town budget" id="{ad44c18f-bc6e-2376-be5c-f637ee0c52b0}">
           <p14:sldIdLst>
             <p14:sldId id="262"/>
           </p14:sldIdLst>
@@ -171,7 +171,7 @@
             <a:pPr>
               <a:defRPr sz="1400" b="0" i="0" u="none" strike="noStrike">
                 <a:solidFill>
-                  <a:srgbClr val="1F2A2E"/>
+                  <a:srgbClr val="141F3E"/>
                 </a:solidFill>
                 <a:latin typeface="+mn-lt"/>
               </a:defRPr>
@@ -179,7 +179,7 @@
             <a:r>
               <a:rPr sz="1400" b="0" i="0" u="none" strike="noStrike">
                 <a:solidFill>
-                  <a:srgbClr val="1F2A2E"/>
+                  <a:srgbClr val="141F3E"/>
                 </a:solidFill>
                 <a:latin typeface="+mn-lt"/>
               </a:rPr>
@@ -212,11 +212,11 @@
           </c:tx>
           <c:spPr>
             <a:solidFill>
-              <a:srgbClr val="2F6F62"/>
+              <a:srgbClr val="9DC058"/>
             </a:solidFill>
             <a:ln w="38100" cap="flat">
               <a:solidFill>
-                <a:srgbClr val="2F6F62"/>
+                <a:srgbClr val="9DC058"/>
               </a:solidFill>
               <a:prstDash val="solid"/>
               <a:round/>
@@ -253,11 +253,11 @@
             <c:size val="6"/>
             <c:spPr>
               <a:solidFill>
-                <a:srgbClr val="2F6F62"/>
+                <a:srgbClr val="9DC058"/>
               </a:solidFill>
               <a:ln w="9525" cap="flat">
                 <a:solidFill>
-                  <a:srgbClr val="2F6F62"/>
+                  <a:srgbClr val="9DC058"/>
                 </a:solidFill>
                 <a:prstDash val="solid"/>
                 <a:round/>
@@ -404,11 +404,11 @@
           </c:tx>
           <c:spPr>
             <a:solidFill>
-              <a:srgbClr val="7A8580"/>
+              <a:srgbClr val="6E7681"/>
             </a:solidFill>
             <a:ln w="38100" cap="flat">
               <a:solidFill>
-                <a:srgbClr val="7A8580"/>
+                <a:srgbClr val="6E7681"/>
               </a:solidFill>
               <a:prstDash val="solid"/>
               <a:round/>
@@ -445,11 +445,11 @@
             <c:size val="6"/>
             <c:spPr>
               <a:solidFill>
-                <a:srgbClr val="7A8580"/>
+                <a:srgbClr val="6E7681"/>
               </a:solidFill>
               <a:ln w="9525" cap="flat">
                 <a:solidFill>
-                  <a:srgbClr val="7A8580"/>
+                  <a:srgbClr val="6E7681"/>
                 </a:solidFill>
                 <a:prstDash val="solid"/>
                 <a:round/>
@@ -623,7 +623,7 @@
         <c:spPr>
           <a:ln w="12700" cap="flat">
             <a:solidFill>
-              <a:srgbClr val="D9DFDC"/>
+              <a:srgbClr val="E3E3E3"/>
             </a:solidFill>
             <a:prstDash val="solid"/>
             <a:round/>
@@ -636,7 +636,7 @@
             <a:pPr>
               <a:defRPr sz="1200" b="0" i="0" u="none" strike="noStrike">
                 <a:solidFill>
-                  <a:srgbClr val="5E6B66"/>
+                  <a:srgbClr val="5F6670"/>
                 </a:solidFill>
                 <a:latin typeface="+mn-lt"/>
               </a:defRPr>
@@ -663,7 +663,7 @@
           <c:spPr>
             <a:ln w="9525" cap="flat">
               <a:solidFill>
-                <a:srgbClr val="D9DFDC"/>
+                <a:srgbClr val="E3E3E3"/>
               </a:solidFill>
               <a:prstDash val="solid"/>
               <a:round/>
@@ -688,7 +688,7 @@
             <a:pPr>
               <a:defRPr sz="1200" b="0" i="0" u="none" strike="noStrike">
                 <a:solidFill>
-                  <a:srgbClr val="5E6B66"/>
+                  <a:srgbClr val="5F6670"/>
                 </a:solidFill>
                 <a:latin typeface="+mn-lt"/>
               </a:defRPr>
@@ -718,7 +718,7 @@
           <a:pPr>
             <a:defRPr sz="1300">
               <a:solidFill>
-                <a:srgbClr val="1F2A2E"/>
+                <a:srgbClr val="141F3E"/>
               </a:solidFill>
               <a:latin typeface="+mn-lt"/>
               <a:cs typeface="+mn-lt"/>
@@ -758,7 +758,7 @@
             <a:pPr>
               <a:defRPr sz="1400" b="0" i="0" u="none" strike="noStrike">
                 <a:solidFill>
-                  <a:srgbClr val="1F2A2E"/>
+                  <a:srgbClr val="141F3E"/>
                 </a:solidFill>
                 <a:latin typeface="+mn-lt"/>
               </a:defRPr>
@@ -766,7 +766,7 @@
             <a:r>
               <a:rPr sz="1400" b="0" i="0" u="none" strike="noStrike">
                 <a:solidFill>
-                  <a:srgbClr val="1F2A2E"/>
+                  <a:srgbClr val="141F3E"/>
                 </a:solidFill>
                 <a:latin typeface="+mn-lt"/>
               </a:rPr>
@@ -801,7 +801,7 @@
           </c:tx>
           <c:spPr>
             <a:solidFill>
-              <a:srgbClr val="9DB5AC"/>
+              <a:srgbClr val="CBE793"/>
             </a:solidFill>
             <a:effectLst/>
           </c:spPr>
@@ -815,7 +815,7 @@
                 <a:pPr>
                   <a:defRPr b="0" i="0" strike="noStrike" sz="1000" u="none">
                     <a:solidFill>
-                      <a:srgbClr val="1F2A2E"/>
+                      <a:srgbClr val="141F3E"/>
                     </a:solidFill>
                     <a:latin typeface="+mn-lt"/>
                   </a:defRPr>
@@ -908,7 +908,7 @@
           </c:tx>
           <c:spPr>
             <a:solidFill>
-              <a:srgbClr val="23423A"/>
+              <a:srgbClr val="141F3E"/>
             </a:solidFill>
             <a:effectLst/>
           </c:spPr>
@@ -922,7 +922,7 @@
                 <a:pPr>
                   <a:defRPr b="0" i="0" strike="noStrike" sz="1000" u="none">
                     <a:solidFill>
-                      <a:srgbClr val="1F2A2E"/>
+                      <a:srgbClr val="141F3E"/>
                     </a:solidFill>
                     <a:latin typeface="+mn-lt"/>
                   </a:defRPr>
@@ -1008,7 +1008,7 @@
               <a:pPr>
                 <a:defRPr b="0" i="0" strike="noStrike" sz="1000" u="none">
                   <a:solidFill>
-                    <a:srgbClr val="1F2A2E"/>
+                    <a:srgbClr val="141F3E"/>
                   </a:solidFill>
                   <a:latin typeface="+mn-lt"/>
                 </a:defRPr>
@@ -1043,7 +1043,7 @@
         <c:spPr>
           <a:ln w="12700" cap="flat">
             <a:solidFill>
-              <a:srgbClr val="D9DFDC"/>
+              <a:srgbClr val="E3E3E3"/>
             </a:solidFill>
             <a:prstDash val="solid"/>
             <a:round/>
@@ -1056,7 +1056,7 @@
             <a:pPr>
               <a:defRPr sz="1200" b="0" i="0" u="none" strike="noStrike">
                 <a:solidFill>
-                  <a:srgbClr val="5E6B66"/>
+                  <a:srgbClr val="5F6670"/>
                 </a:solidFill>
                 <a:latin typeface="+mn-lt"/>
               </a:defRPr>
@@ -1082,7 +1082,7 @@
           <c:spPr>
             <a:ln w="9525" cap="flat">
               <a:solidFill>
-                <a:srgbClr val="D9DFDC"/>
+                <a:srgbClr val="E3E3E3"/>
               </a:solidFill>
               <a:prstDash val="solid"/>
               <a:round/>
@@ -1107,7 +1107,7 @@
             <a:pPr>
               <a:defRPr sz="1200" b="0" i="0" u="none" strike="noStrike">
                 <a:solidFill>
-                  <a:srgbClr val="5E6B66"/>
+                  <a:srgbClr val="5F6670"/>
                 </a:solidFill>
                 <a:latin typeface="+mn-lt"/>
               </a:defRPr>
@@ -1137,7 +1137,7 @@
           <a:pPr>
             <a:defRPr sz="1300">
               <a:solidFill>
-                <a:srgbClr val="1F2A2E"/>
+                <a:srgbClr val="141F3E"/>
               </a:solidFill>
               <a:latin typeface="+mn-lt"/>
               <a:cs typeface="+mn-lt"/>
@@ -1177,7 +1177,7 @@
             <a:pPr>
               <a:defRPr sz="1400" b="0" i="0" u="none" strike="noStrike">
                 <a:solidFill>
-                  <a:srgbClr val="1F2A2E"/>
+                  <a:srgbClr val="141F3E"/>
                 </a:solidFill>
                 <a:latin typeface="+mn-lt"/>
               </a:defRPr>
@@ -1185,7 +1185,7 @@
             <a:r>
               <a:rPr sz="1400" b="0" i="0" u="none" strike="noStrike">
                 <a:solidFill>
-                  <a:srgbClr val="1F2A2E"/>
+                  <a:srgbClr val="141F3E"/>
                 </a:solidFill>
                 <a:latin typeface="+mn-lt"/>
               </a:rPr>
@@ -1220,7 +1220,7 @@
           </c:tx>
           <c:spPr>
             <a:solidFill>
-              <a:srgbClr val="9DB5AC"/>
+              <a:srgbClr val="CBE793"/>
             </a:solidFill>
             <a:effectLst/>
           </c:spPr>
@@ -1234,7 +1234,7 @@
                 <a:pPr>
                   <a:defRPr b="0" i="0" strike="noStrike" sz="1100" u="none">
                     <a:solidFill>
-                      <a:srgbClr val="1F2A2E"/>
+                      <a:srgbClr val="141F3E"/>
                     </a:solidFill>
                     <a:latin typeface="+mn-lt"/>
                   </a:defRPr>
@@ -1297,7 +1297,7 @@
           </c:tx>
           <c:spPr>
             <a:solidFill>
-              <a:srgbClr val="E0A458"/>
+              <a:srgbClr val="9DC058"/>
             </a:solidFill>
             <a:effectLst/>
           </c:spPr>
@@ -1311,7 +1311,7 @@
                 <a:pPr>
                   <a:defRPr b="0" i="0" strike="noStrike" sz="1100" u="none">
                     <a:solidFill>
-                      <a:srgbClr val="1F2A2E"/>
+                      <a:srgbClr val="141F3E"/>
                     </a:solidFill>
                     <a:latin typeface="+mn-lt"/>
                   </a:defRPr>
@@ -1374,7 +1374,7 @@
           </c:tx>
           <c:spPr>
             <a:solidFill>
-              <a:srgbClr val="23423A"/>
+              <a:srgbClr val="141F3E"/>
             </a:solidFill>
             <a:effectLst/>
           </c:spPr>
@@ -1388,7 +1388,7 @@
                 <a:pPr>
                   <a:defRPr b="0" i="0" strike="noStrike" sz="1100" u="none">
                     <a:solidFill>
-                      <a:srgbClr val="1F2A2E"/>
+                      <a:srgbClr val="141F3E"/>
                     </a:solidFill>
                     <a:latin typeface="+mn-lt"/>
                   </a:defRPr>
@@ -1444,7 +1444,7 @@
               <a:pPr>
                 <a:defRPr b="0" i="0" strike="noStrike" sz="1100" u="none">
                   <a:solidFill>
-                    <a:srgbClr val="1F2A2E"/>
+                    <a:srgbClr val="141F3E"/>
                   </a:solidFill>
                   <a:latin typeface="+mn-lt"/>
                 </a:defRPr>
@@ -1479,7 +1479,7 @@
         <c:spPr>
           <a:ln w="12700" cap="flat">
             <a:solidFill>
-              <a:srgbClr val="D9DFDC"/>
+              <a:srgbClr val="E3E3E3"/>
             </a:solidFill>
             <a:prstDash val="solid"/>
             <a:round/>
@@ -1492,7 +1492,7 @@
             <a:pPr>
               <a:defRPr sz="1300" b="0" i="0" u="none" strike="noStrike">
                 <a:solidFill>
-                  <a:srgbClr val="5E6B66"/>
+                  <a:srgbClr val="5F6670"/>
                 </a:solidFill>
                 <a:latin typeface="+mn-lt"/>
               </a:defRPr>
@@ -1518,7 +1518,7 @@
           <c:spPr>
             <a:ln w="9525" cap="flat">
               <a:solidFill>
-                <a:srgbClr val="D9DFDC"/>
+                <a:srgbClr val="E3E3E3"/>
               </a:solidFill>
               <a:prstDash val="solid"/>
               <a:round/>
@@ -1543,7 +1543,7 @@
             <a:pPr>
               <a:defRPr sz="1200" b="0" i="0" u="none" strike="noStrike">
                 <a:solidFill>
-                  <a:srgbClr val="5E6B66"/>
+                  <a:srgbClr val="5F6670"/>
                 </a:solidFill>
                 <a:latin typeface="+mn-lt"/>
               </a:defRPr>
@@ -1573,7 +1573,7 @@
           <a:pPr>
             <a:defRPr sz="1300">
               <a:solidFill>
-                <a:srgbClr val="1F2A2E"/>
+                <a:srgbClr val="141F3E"/>
               </a:solidFill>
               <a:latin typeface="+mn-lt"/>
               <a:cs typeface="+mn-lt"/>
@@ -1613,7 +1613,7 @@
             <a:pPr>
               <a:defRPr sz="1400" b="0" i="0" u="none" strike="noStrike">
                 <a:solidFill>
-                  <a:srgbClr val="1F2A2E"/>
+                  <a:srgbClr val="141F3E"/>
                 </a:solidFill>
                 <a:latin typeface="+mn-lt"/>
               </a:defRPr>
@@ -1621,7 +1621,7 @@
             <a:r>
               <a:rPr sz="1400" b="0" i="0" u="none" strike="noStrike">
                 <a:solidFill>
-                  <a:srgbClr val="1F2A2E"/>
+                  <a:srgbClr val="141F3E"/>
                 </a:solidFill>
                 <a:latin typeface="+mn-lt"/>
               </a:rPr>
@@ -1654,11 +1654,11 @@
           </c:tx>
           <c:spPr>
             <a:solidFill>
-              <a:srgbClr val="C8553D"/>
+              <a:srgbClr val="141F3E"/>
             </a:solidFill>
             <a:ln w="38100" cap="flat">
               <a:solidFill>
-                <a:srgbClr val="C8553D"/>
+                <a:srgbClr val="141F3E"/>
               </a:solidFill>
               <a:prstDash val="solid"/>
               <a:round/>
@@ -1695,11 +1695,11 @@
             <c:size val="6"/>
             <c:spPr>
               <a:solidFill>
-                <a:srgbClr val="C8553D"/>
+                <a:srgbClr val="141F3E"/>
               </a:solidFill>
               <a:ln w="9525" cap="flat">
                 <a:solidFill>
-                  <a:srgbClr val="C8553D"/>
+                  <a:srgbClr val="141F3E"/>
                 </a:solidFill>
                 <a:prstDash val="solid"/>
                 <a:round/>
@@ -1846,11 +1846,11 @@
           </c:tx>
           <c:spPr>
             <a:solidFill>
-              <a:srgbClr val="2F6F62"/>
+              <a:srgbClr val="9DC058"/>
             </a:solidFill>
             <a:ln w="38100" cap="flat">
               <a:solidFill>
-                <a:srgbClr val="2F6F62"/>
+                <a:srgbClr val="9DC058"/>
               </a:solidFill>
               <a:prstDash val="solid"/>
               <a:round/>
@@ -1887,11 +1887,11 @@
             <c:size val="6"/>
             <c:spPr>
               <a:solidFill>
-                <a:srgbClr val="2F6F62"/>
+                <a:srgbClr val="9DC058"/>
               </a:solidFill>
               <a:ln w="9525" cap="flat">
                 <a:solidFill>
-                  <a:srgbClr val="2F6F62"/>
+                  <a:srgbClr val="9DC058"/>
                 </a:solidFill>
                 <a:prstDash val="solid"/>
                 <a:round/>
@@ -2038,11 +2038,11 @@
           </c:tx>
           <c:spPr>
             <a:solidFill>
-              <a:srgbClr val="7A8580"/>
+              <a:srgbClr val="6E7681"/>
             </a:solidFill>
             <a:ln w="38100" cap="flat">
               <a:solidFill>
-                <a:srgbClr val="7A8580"/>
+                <a:srgbClr val="6E7681"/>
               </a:solidFill>
               <a:prstDash val="solid"/>
               <a:round/>
@@ -2079,11 +2079,11 @@
             <c:size val="6"/>
             <c:spPr>
               <a:solidFill>
-                <a:srgbClr val="7A8580"/>
+                <a:srgbClr val="6E7681"/>
               </a:solidFill>
               <a:ln w="9525" cap="flat">
                 <a:solidFill>
-                  <a:srgbClr val="7A8580"/>
+                  <a:srgbClr val="6E7681"/>
                 </a:solidFill>
                 <a:prstDash val="solid"/>
                 <a:round/>
@@ -2257,7 +2257,7 @@
         <c:spPr>
           <a:ln w="12700" cap="flat">
             <a:solidFill>
-              <a:srgbClr val="D9DFDC"/>
+              <a:srgbClr val="E3E3E3"/>
             </a:solidFill>
             <a:prstDash val="solid"/>
             <a:round/>
@@ -2270,7 +2270,7 @@
             <a:pPr>
               <a:defRPr sz="1200" b="0" i="0" u="none" strike="noStrike">
                 <a:solidFill>
-                  <a:srgbClr val="5E6B66"/>
+                  <a:srgbClr val="5F6670"/>
                 </a:solidFill>
                 <a:latin typeface="+mn-lt"/>
               </a:defRPr>
@@ -2297,7 +2297,7 @@
           <c:spPr>
             <a:ln w="9525" cap="flat">
               <a:solidFill>
-                <a:srgbClr val="D9DFDC"/>
+                <a:srgbClr val="E3E3E3"/>
               </a:solidFill>
               <a:prstDash val="solid"/>
               <a:round/>
@@ -2322,7 +2322,7 @@
             <a:pPr>
               <a:defRPr sz="1200" b="0" i="0" u="none" strike="noStrike">
                 <a:solidFill>
-                  <a:srgbClr val="5E6B66"/>
+                  <a:srgbClr val="5F6670"/>
                 </a:solidFill>
                 <a:latin typeface="+mn-lt"/>
               </a:defRPr>
@@ -2352,7 +2352,7 @@
           <a:pPr>
             <a:defRPr sz="1300">
               <a:solidFill>
-                <a:srgbClr val="1F2A2E"/>
+                <a:srgbClr val="141F3E"/>
               </a:solidFill>
               <a:latin typeface="+mn-lt"/>
               <a:cs typeface="+mn-lt"/>
@@ -2392,7 +2392,7 @@
             <a:pPr>
               <a:defRPr sz="1400" b="0" i="0" u="none" strike="noStrike">
                 <a:solidFill>
-                  <a:srgbClr val="1F2A2E"/>
+                  <a:srgbClr val="141F3E"/>
                 </a:solidFill>
                 <a:latin typeface="+mn-lt"/>
               </a:defRPr>
@@ -2400,7 +2400,7 @@
             <a:r>
               <a:rPr sz="1400" b="0" i="0" u="none" strike="noStrike">
                 <a:solidFill>
-                  <a:srgbClr val="1F2A2E"/>
+                  <a:srgbClr val="141F3E"/>
                 </a:solidFill>
                 <a:latin typeface="+mn-lt"/>
               </a:rPr>
@@ -2435,7 +2435,7 @@
           </c:tx>
           <c:spPr>
             <a:solidFill>
-              <a:srgbClr val="2F6F62"/>
+              <a:srgbClr val="9DC058"/>
             </a:solidFill>
             <a:effectLst/>
           </c:spPr>
@@ -2449,7 +2449,7 @@
                 <a:pPr>
                   <a:defRPr b="0" i="0" strike="noStrike" sz="1200" u="none">
                     <a:solidFill>
-                      <a:srgbClr val="1F2A2E"/>
+                      <a:srgbClr val="141F3E"/>
                     </a:solidFill>
                     <a:latin typeface="+mn-lt"/>
                   </a:defRPr>
@@ -2470,7 +2470,7 @@
             <c:bubble3D val="0"/>
             <c:spPr>
               <a:solidFill>
-                <a:srgbClr val="2F6F62"/>
+                <a:srgbClr val="9DC058"/>
               </a:solidFill>
               <a:effectLst/>
             </c:spPr>
@@ -2481,7 +2481,7 @@
             <c:bubble3D val="0"/>
             <c:spPr>
               <a:solidFill>
-                <a:srgbClr val="2F6F62"/>
+                <a:srgbClr val="9DC058"/>
               </a:solidFill>
               <a:effectLst/>
             </c:spPr>
@@ -2492,7 +2492,7 @@
             <c:bubble3D val="0"/>
             <c:spPr>
               <a:solidFill>
-                <a:srgbClr val="9DB5AC"/>
+                <a:srgbClr val="CBE793"/>
               </a:solidFill>
               <a:effectLst/>
             </c:spPr>
@@ -2503,7 +2503,7 @@
             <c:bubble3D val="0"/>
             <c:spPr>
               <a:solidFill>
-                <a:srgbClr val="2F6F62"/>
+                <a:srgbClr val="9DC058"/>
               </a:solidFill>
               <a:effectLst/>
             </c:spPr>
@@ -2514,7 +2514,7 @@
             <c:bubble3D val="0"/>
             <c:spPr>
               <a:solidFill>
-                <a:srgbClr val="2F6F62"/>
+                <a:srgbClr val="9DC058"/>
               </a:solidFill>
               <a:effectLst/>
             </c:spPr>
@@ -2525,7 +2525,7 @@
             <c:bubble3D val="0"/>
             <c:spPr>
               <a:solidFill>
-                <a:srgbClr val="9DB5AC"/>
+                <a:srgbClr val="CBE793"/>
               </a:solidFill>
               <a:effectLst/>
             </c:spPr>
@@ -2536,7 +2536,7 @@
             <c:bubble3D val="0"/>
             <c:spPr>
               <a:solidFill>
-                <a:srgbClr val="C8553D"/>
+                <a:srgbClr val="141F3E"/>
               </a:solidFill>
               <a:effectLst/>
             </c:spPr>
@@ -2612,7 +2612,7 @@
               <a:pPr>
                 <a:defRPr b="0" i="0" strike="noStrike" sz="1200" u="none">
                   <a:solidFill>
-                    <a:srgbClr val="1F2A2E"/>
+                    <a:srgbClr val="141F3E"/>
                   </a:solidFill>
                   <a:latin typeface="+mn-lt"/>
                 </a:defRPr>
@@ -2647,7 +2647,7 @@
         <c:spPr>
           <a:ln w="12700" cap="flat">
             <a:solidFill>
-              <a:srgbClr val="D9DFDC"/>
+              <a:srgbClr val="E3E3E3"/>
             </a:solidFill>
             <a:prstDash val="solid"/>
             <a:round/>
@@ -2660,7 +2660,7 @@
             <a:pPr>
               <a:defRPr sz="1200" b="0" i="0" u="none" strike="noStrike">
                 <a:solidFill>
-                  <a:srgbClr val="5E6B66"/>
+                  <a:srgbClr val="5F6670"/>
                 </a:solidFill>
                 <a:latin typeface="+mn-lt"/>
               </a:defRPr>
@@ -2701,7 +2701,7 @@
             <a:pPr>
               <a:defRPr sz="1200" b="0" i="0" u="none" strike="noStrike">
                 <a:solidFill>
-                  <a:srgbClr val="5E6B66"/>
+                  <a:srgbClr val="5F6670"/>
                 </a:solidFill>
                 <a:latin typeface="+mn-lt"/>
               </a:defRPr>
@@ -2751,7 +2751,7 @@
             <a:pPr>
               <a:defRPr sz="1400" b="0" i="0" u="none" strike="noStrike">
                 <a:solidFill>
-                  <a:srgbClr val="1F2A2E"/>
+                  <a:srgbClr val="141F3E"/>
                 </a:solidFill>
                 <a:latin typeface="+mn-lt"/>
               </a:defRPr>
@@ -2759,7 +2759,7 @@
             <a:r>
               <a:rPr sz="1400" b="0" i="0" u="none" strike="noStrike">
                 <a:solidFill>
-                  <a:srgbClr val="1F2A2E"/>
+                  <a:srgbClr val="141F3E"/>
                 </a:solidFill>
                 <a:latin typeface="+mn-lt"/>
               </a:rPr>
@@ -2794,7 +2794,7 @@
           </c:tx>
           <c:spPr>
             <a:solidFill>
-              <a:srgbClr val="C8553D"/>
+              <a:srgbClr val="141F3E"/>
             </a:solidFill>
             <a:effectLst/>
           </c:spPr>
@@ -2808,7 +2808,7 @@
                 <a:pPr>
                   <a:defRPr b="0" i="0" strike="noStrike" sz="1200" u="none">
                     <a:solidFill>
-                      <a:srgbClr val="1F2A2E"/>
+                      <a:srgbClr val="141F3E"/>
                     </a:solidFill>
                     <a:latin typeface="+mn-lt"/>
                   </a:defRPr>
@@ -2829,7 +2829,7 @@
             <c:bubble3D val="0"/>
             <c:spPr>
               <a:solidFill>
-                <a:srgbClr val="C8553D"/>
+                <a:srgbClr val="141F3E"/>
               </a:solidFill>
               <a:effectLst/>
             </c:spPr>
@@ -2840,7 +2840,7 @@
             <c:bubble3D val="0"/>
             <c:spPr>
               <a:solidFill>
-                <a:srgbClr val="2F6F62"/>
+                <a:srgbClr val="9DC058"/>
               </a:solidFill>
               <a:effectLst/>
             </c:spPr>
@@ -2851,7 +2851,7 @@
             <c:bubble3D val="0"/>
             <c:spPr>
               <a:solidFill>
-                <a:srgbClr val="2F6F62"/>
+                <a:srgbClr val="9DC058"/>
               </a:solidFill>
               <a:effectLst/>
             </c:spPr>
@@ -2862,7 +2862,7 @@
             <c:bubble3D val="0"/>
             <c:spPr>
               <a:solidFill>
-                <a:srgbClr val="2F6F62"/>
+                <a:srgbClr val="9DC058"/>
               </a:solidFill>
               <a:effectLst/>
             </c:spPr>
@@ -2873,7 +2873,7 @@
             <c:bubble3D val="0"/>
             <c:spPr>
               <a:solidFill>
-                <a:srgbClr val="9DB5AC"/>
+                <a:srgbClr val="CBE793"/>
               </a:solidFill>
               <a:effectLst/>
             </c:spPr>
@@ -2884,7 +2884,7 @@
             <c:bubble3D val="0"/>
             <c:spPr>
               <a:solidFill>
-                <a:srgbClr val="9DB5AC"/>
+                <a:srgbClr val="CBE793"/>
               </a:solidFill>
               <a:effectLst/>
             </c:spPr>
@@ -2954,7 +2954,7 @@
               <a:pPr>
                 <a:defRPr b="0" i="0" strike="noStrike" sz="1200" u="none">
                   <a:solidFill>
-                    <a:srgbClr val="1F2A2E"/>
+                    <a:srgbClr val="141F3E"/>
                   </a:solidFill>
                   <a:latin typeface="+mn-lt"/>
                 </a:defRPr>
@@ -2989,7 +2989,7 @@
         <c:spPr>
           <a:ln w="12700" cap="flat">
             <a:solidFill>
-              <a:srgbClr val="D9DFDC"/>
+              <a:srgbClr val="E3E3E3"/>
             </a:solidFill>
             <a:prstDash val="solid"/>
             <a:round/>
@@ -3002,7 +3002,7 @@
             <a:pPr>
               <a:defRPr sz="1200" b="0" i="0" u="none" strike="noStrike">
                 <a:solidFill>
-                  <a:srgbClr val="5E6B66"/>
+                  <a:srgbClr val="5F6670"/>
                 </a:solidFill>
                 <a:latin typeface="+mn-lt"/>
               </a:defRPr>
@@ -3043,7 +3043,7 @@
             <a:pPr>
               <a:defRPr sz="1200" b="0" i="0" u="none" strike="noStrike">
                 <a:solidFill>
-                  <a:srgbClr val="5E6B66"/>
+                  <a:srgbClr val="5F6670"/>
                 </a:solidFill>
                 <a:latin typeface="+mn-lt"/>
               </a:defRPr>
@@ -4183,7 +4183,7 @@
               <a:buNone/>
               <a:defRPr lang="en-US" sz="1800" dirty="0">
                 <a:solidFill>
-                  <a:schemeClr val="bg2"/>
+                  <a:srgbClr val="CBE793"/>
                 </a:solidFill>
               </a:defRPr>
             </a:lvl1pPr>
@@ -4803,7 +4803,7 @@
             <a:r>
               <a:rPr lang="en-US" sz="1800" dirty="0">
                 <a:solidFill>
-                  <a:schemeClr val="bg2"/>
+                  <a:srgbClr val="CBE793"/>
                 </a:solidFill>
               </a:rPr>
               <a:t>Per-pupil spending at Leverett Elementary, 2009–2025, compared with the ARPS towns and Western Massachusetts</a:t>
@@ -5597,7 +5597,7 @@
             <a:r>
               <a:rPr lang="en-US" sz="1600" i="1" dirty="0">
                 <a:solidFill>
-                  <a:schemeClr val="accent2"/>
+                  <a:schemeClr val="accent5"/>
                 </a:solidFill>
               </a:rPr>
               <a:t>Today's high spending is a legacy of a high starting point, not runaway growth.</a:t>
@@ -6429,7 +6429,7 @@
             <a:r>
               <a:rPr lang="en-US" sz="1600" i="1" dirty="0">
                 <a:solidFill>
-                  <a:schemeClr val="accent2"/>
+                  <a:schemeClr val="accent5"/>
                 </a:solidFill>
               </a:rPr>
               <a:t>The town carries more of the cost, and its educators absorb part of it in pay. The structural fix sits with the state's funding formula.</a:t>
@@ -6813,42 +6813,42 @@
 <file path=ppt/theme/theme1.xml><?xml version="1.0" encoding="utf-8"?>
 <a:theme xmlns:a="http://schemas.openxmlformats.org/drawingml/2006/main" name="Office Theme">
   <a:themeElements>
-    <a:clrScheme name="Leverett Forum">
+    <a:clrScheme name="Leverett Elementary">
       <a:dk1>
-        <a:srgbClr val="1F2A2E"/>
+        <a:srgbClr val="141F3E"/>
       </a:dk1>
       <a:lt1>
         <a:srgbClr val="FFFFFF"/>
       </a:lt1>
       <a:dk2>
-        <a:srgbClr val="23423A"/>
+        <a:srgbClr val="141F3E"/>
       </a:dk2>
       <a:lt2>
-        <a:srgbClr val="EEF2EF"/>
+        <a:srgbClr val="DCE9EA"/>
       </a:lt2>
       <a:accent1>
-        <a:srgbClr val="C8553D"/>
+        <a:srgbClr val="141F3E"/>
       </a:accent1>
       <a:accent2>
-        <a:srgbClr val="2F6F62"/>
+        <a:srgbClr val="9DC058"/>
       </a:accent2>
       <a:accent3>
-        <a:srgbClr val="9DB5AC"/>
+        <a:srgbClr val="CBE793"/>
       </a:accent3>
       <a:accent4>
-        <a:srgbClr val="E0A458"/>
+        <a:srgbClr val="DCE9EA"/>
       </a:accent4>
       <a:accent5>
-        <a:srgbClr val="5B6C8F"/>
+        <a:srgbClr val="035D58"/>
       </a:accent5>
       <a:accent6>
-        <a:srgbClr val="7A8580"/>
+        <a:srgbClr val="6E7681"/>
       </a:accent6>
       <a:hlink>
-        <a:srgbClr val="2F6F62"/>
+        <a:srgbClr val="035D58"/>
       </a:hlink>
       <a:folHlink>
-        <a:srgbClr val="5B6C8F"/>
+        <a:srgbClr val="202D53"/>
       </a:folHlink>
     </a:clrScheme>
     <a:fontScheme name="Office">

</xml_diff>